<commit_message>
Plants vs. Zombies deck: same essentials, different form
Grids vs. objects with the order of checks, the class tree, where
inheritance breaks as four cases, what components cost, and Prototype
vs. Type Object side by side; old text in the speaker notes and the
site's Check yourself questions at the end.

Co-Authored-By: Claude Opus 5.5 <noreply@anthropic.com>
Claude-Session: https://claude.ai/code/session_012sjsUQBbC7zon57rWHoo9d
</commit_message>
<xml_diff>
--- a/slides/09 Plants vs. Zombies.pptx
+++ b/slides/09 Plants vs. Zombies.pptx
@@ -31,6 +31,7 @@
     <p:sldId id="280" r:id="rId30"/>
     <p:sldId id="292" r:id="rId42"/>
     <p:sldId id="293" r:id="rId52"/>
+    <p:sldId id="313" r:id="rId40"/>
     <p:sldId id="294" r:id="rId53"/>
     <p:sldId id="296" r:id="rId55"/>
   </p:sldIdLst>
@@ -829,6 +830,250 @@
 </p:notes>
 </file>
 
+<file path=ppt/notesSlides/notesSlide10.xml><?xml version="1.0" encoding="utf-8"?>
+<p:notes xmlns:a="http://schemas.openxmlformats.org/drawingml/2006/main" xmlns:p="http://schemas.openxmlformats.org/presentationml/2006/main" xmlns:r="http://schemas.openxmlformats.org/officeDocument/2006/relationships">
+  <p:cSld>
+    <p:spTree>
+      <p:nvGrpSpPr>
+        <p:cNvPr id="1" name=""/>
+        <p:cNvGrpSpPr/>
+        <p:nvPr/>
+      </p:nvGrpSpPr>
+      <p:grpSpPr>
+        <a:xfrm>
+          <a:off x="0" y="0"/>
+          <a:ext cx="0" cy="0"/>
+          <a:chOff x="0" y="0"/>
+          <a:chExt cx="0" cy="0"/>
+        </a:xfrm>
+      </p:grpSpPr>
+      <p:sp>
+        <p:nvSpPr>
+          <p:cNvPr id="2" name="Slide Image Placeholder 1"/>
+          <p:cNvSpPr>
+            <a:spLocks noGrp="1"/>
+          </p:cNvSpPr>
+          <p:nvPr>
+            <p:ph type="sldImg" idx="2"/>
+          </p:nvPr>
+        </p:nvSpPr>
+        <p:spPr/>
+      </p:sp>
+      <p:sp>
+        <p:nvSpPr>
+          <p:cNvPr id="3" name="Notes Placeholder 2"/>
+          <p:cNvSpPr>
+            <a:spLocks noGrp="1"/>
+          </p:cNvSpPr>
+          <p:nvPr>
+            <p:ph type="body" idx="1"/>
+          </p:nvPr>
+        </p:nvSpPr>
+        <p:spPr/>
+        <p:txBody>
+          <a:bodyPr/>
+          <a:lstStyle/>
+          <a:p>
+            <a:r>
+              <a:t>Talking points:</a:t>
+            </a:r>
+          </a:p>
+          <a:p>
+            <a:r>
+              <a:t>- Finding each other takes code</a:t>
+            </a:r>
+          </a:p>
+          <a:p>
+            <a:r>
+              <a:t>  - Get&lt;Eater&gt;() searches a list, and may return null</a:t>
+            </a:r>
+          </a:p>
+          <a:p>
+            <a:r>
+              <a:t>- Order matters</a:t>
+            </a:r>
+          </a:p>
+          <a:p>
+            <a:r>
+              <a:t>  - Components update and draw in the order they were added</a:t>
+            </a:r>
+          </a:p>
+          <a:p>
+            <a:r>
+              <a:t>- Where does a rule go?</a:t>
+            </a:r>
+          </a:p>
+          <a:p>
+            <a:r>
+              <a:t>  - A pea hits a zombie: the pea’s rule, or the zombie’s?</a:t>
+            </a:r>
+          </a:p>
+          <a:p>
+            <a:r>
+              <a:t>  - Geometry Wars moves such rules into systems</a:t>
+            </a:r>
+          </a:p>
+        </p:txBody>
+      </p:sp>
+    </p:spTree>
+  </p:cSld>
+  <p:clrMapOvr>
+    <a:masterClrMapping/>
+  </p:clrMapOvr>
+</p:notes>
+</file>
+
+<file path=ppt/notesSlides/notesSlide11.xml><?xml version="1.0" encoding="utf-8"?>
+<p:notes xmlns:a="http://schemas.openxmlformats.org/drawingml/2006/main" xmlns:p="http://schemas.openxmlformats.org/presentationml/2006/main" xmlns:r="http://schemas.openxmlformats.org/officeDocument/2006/relationships">
+  <p:cSld>
+    <p:spTree>
+      <p:nvGrpSpPr>
+        <p:cNvPr id="1" name=""/>
+        <p:cNvGrpSpPr/>
+        <p:nvPr/>
+      </p:nvGrpSpPr>
+      <p:grpSpPr>
+        <a:xfrm>
+          <a:off x="0" y="0"/>
+          <a:ext cx="0" cy="0"/>
+          <a:chOff x="0" y="0"/>
+          <a:chExt cx="0" cy="0"/>
+        </a:xfrm>
+      </p:grpSpPr>
+      <p:sp>
+        <p:nvSpPr>
+          <p:cNvPr id="2" name="Slide Image Placeholder 1"/>
+          <p:cNvSpPr>
+            <a:spLocks noGrp="1"/>
+          </p:cNvSpPr>
+          <p:nvPr>
+            <p:ph type="sldImg" idx="2"/>
+          </p:nvPr>
+        </p:nvSpPr>
+        <p:spPr/>
+      </p:sp>
+      <p:sp>
+        <p:nvSpPr>
+          <p:cNvPr id="3" name="Notes Placeholder 2"/>
+          <p:cNvSpPr>
+            <a:spLocks noGrp="1"/>
+          </p:cNvSpPr>
+          <p:nvPr>
+            <p:ph type="body" idx="1"/>
+          </p:nvPr>
+        </p:nvSpPr>
+        <p:spPr/>
+        <p:txBody>
+          <a:bodyPr/>
+          <a:lstStyle/>
+          <a:p>
+            <a:r>
+              <a:t>Talking points:</a:t>
+            </a:r>
+          </a:p>
+          <a:p>
+            <a:r>
+              <a:t>- Prototype (Angry Birds): copy a configured object</a:t>
+            </a:r>
+          </a:p>
+          <a:p>
+            <a:r>
+              <a:t>  - Shared data is copied into every clone</a:t>
+            </a:r>
+          </a:p>
+          <a:p>
+            <a:r>
+              <a:t>  - Good for “make more like this one”</a:t>
+            </a:r>
+          </a:p>
+          <a:p>
+            <a:r>
+              <a:t>- Type Object: a separate type class creates instances</a:t>
+            </a:r>
+          </a:p>
+          <a:p>
+            <a:r>
+              <a:t>  - Shared data is kept once, in the type</a:t>
+            </a:r>
+          </a:p>
+          <a:p>
+            <a:r>
+              <a:t>  - An instance can refer to its type</a:t>
+            </a:r>
+          </a:p>
+          <a:p>
+            <a:r>
+              <a:t>  - Good for kinds with their own data and rules</a:t>
+            </a:r>
+          </a:p>
+        </p:txBody>
+      </p:sp>
+    </p:spTree>
+  </p:cSld>
+  <p:clrMapOvr>
+    <a:masterClrMapping/>
+  </p:clrMapOvr>
+</p:notes>
+</file>
+
+<file path=ppt/notesSlides/notesSlide12.xml><?xml version="1.0" encoding="utf-8"?>
+<p:notes xmlns:a="http://schemas.openxmlformats.org/drawingml/2006/main" xmlns:p="http://schemas.openxmlformats.org/presentationml/2006/main" xmlns:r="http://schemas.openxmlformats.org/officeDocument/2006/relationships">
+  <p:cSld>
+    <p:spTree>
+      <p:nvGrpSpPr>
+        <p:cNvPr id="1" name=""/>
+        <p:cNvGrpSpPr/>
+        <p:nvPr/>
+      </p:nvGrpSpPr>
+      <p:grpSpPr>
+        <a:xfrm>
+          <a:off x="0" y="0"/>
+          <a:ext cx="0" cy="0"/>
+          <a:chOff x="0" y="0"/>
+          <a:chExt cx="0" cy="0"/>
+        </a:xfrm>
+      </p:grpSpPr>
+      <p:sp>
+        <p:nvSpPr>
+          <p:cNvPr id="2" name="Slide Image Placeholder 1"/>
+          <p:cNvSpPr>
+            <a:spLocks noGrp="1"/>
+          </p:cNvSpPr>
+          <p:nvPr>
+            <p:ph type="sldImg" idx="2"/>
+          </p:nvPr>
+        </p:nvSpPr>
+        <p:spPr/>
+      </p:sp>
+      <p:sp>
+        <p:nvSpPr>
+          <p:cNvPr id="3" name="Notes Placeholder 2"/>
+          <p:cNvSpPr>
+            <a:spLocks noGrp="1"/>
+          </p:cNvSpPr>
+          <p:nvPr>
+            <p:ph type="body" idx="1"/>
+          </p:nvPr>
+        </p:nvSpPr>
+        <p:spPr/>
+        <p:txBody>
+          <a:bodyPr/>
+          <a:lstStyle/>
+          <a:p>
+            <a:r>
+              <a:t>Ask, let them answer in pairs for a minute, then take a few answers. These are the site’s Check yourself questions.</a:t>
+            </a:r>
+          </a:p>
+        </p:txBody>
+      </p:sp>
+    </p:spTree>
+  </p:cSld>
+  <p:clrMapOvr>
+    <a:masterClrMapping/>
+  </p:clrMapOvr>
+</p:notes>
+</file>
+
 <file path=ppt/notesSlides/notesSlide2.xml><?xml version="1.0" encoding="utf-8"?>
 <p:notes xmlns:a="http://schemas.openxmlformats.org/drawingml/2006/main" xmlns:r="http://schemas.openxmlformats.org/officeDocument/2006/relationships" xmlns:mc="http://schemas.openxmlformats.org/markup-compatibility/2006" xmlns:mv="urn:schemas-microsoft-com:mac:vml" xmlns:p="http://schemas.openxmlformats.org/presentationml/2006/main" xmlns:c="http://schemas.openxmlformats.org/drawingml/2006/chart" xmlns:dgm="http://schemas.openxmlformats.org/drawingml/2006/diagram" xmlns:o="urn:schemas-microsoft-com:office:office" xmlns:v="urn:schemas-microsoft-com:vml" xmlns:pvml="urn:schemas-microsoft-com:office:powerpoint" xmlns:com="http://schemas.openxmlformats.org/drawingml/2006/compatibility" xmlns:p14="http://schemas.microsoft.com/office/powerpoint/2010/main" xmlns:p15="http://schemas.microsoft.com/office/powerpoint/2012/main" xmlns:ahyp="http://schemas.microsoft.com/office/drawing/2018/hyperlinkcolor" showMasterPhAnim="0" showMasterSp="0">
   <p:cSld>
@@ -1300,19 +1545,298 @@
           </a:bodyPr>
           <a:lstStyle/>
           <a:p>
-            <a:pPr indent="0" lvl="0" marL="0" rtl="0" algn="l">
-              <a:spcBef>
-                <a:spcPts val="0"/>
-              </a:spcBef>
-              <a:spcAft>
-                <a:spcPts val="0"/>
-              </a:spcAft>
-              <a:buNone/>
-            </a:pPr>
-            <a:r>
-              <a:t/>
-            </a:r>
-            <a:endParaRPr/>
+            <a:r>
+              <a:t>Talking points:</a:t>
+            </a:r>
+          </a:p>
+          <a:p>
+            <a:r>
+              <a:t>- All Source code for today’s game can be found here:</a:t>
+            </a:r>
+          </a:p>
+          <a:p>
+            <a:r>
+              <a:t>  - github.com/Metamate/gar-games (folder 09-plants-vs-zombies)</a:t>
+            </a:r>
+          </a:p>
+          <a:p>
+            <a:r>
+              <a:t>- The game is built up in steps: Pvz0 → Pvz4</a:t>
+            </a:r>
+          </a:p>
+          <a:p>
+            <a:r>
+              <a:t>  - Each step is a separate project that adds one concept</a:t>
+            </a:r>
+          </a:p>
+          <a:p>
+            <a:r>
+              <a:t>  - Compare neighbouring steps to see exactly what changed</a:t>
+            </a:r>
+          </a:p>
+          <a:p>
+            <a:r>
+              <a:t>- Pvz4 is the finished game, and the starting point for the exercises</a:t>
+            </a:r>
+          </a:p>
+        </p:txBody>
+      </p:sp>
+    </p:spTree>
+  </p:cSld>
+  <p:clrMapOvr>
+    <a:masterClrMapping/>
+  </p:clrMapOvr>
+</p:notes>
+</file>
+
+<file path=ppt/notesSlides/notesSlide7.xml><?xml version="1.0" encoding="utf-8"?>
+<p:notes xmlns:a="http://schemas.openxmlformats.org/drawingml/2006/main" xmlns:p="http://schemas.openxmlformats.org/presentationml/2006/main" xmlns:r="http://schemas.openxmlformats.org/officeDocument/2006/relationships">
+  <p:cSld>
+    <p:spTree>
+      <p:nvGrpSpPr>
+        <p:cNvPr id="1" name=""/>
+        <p:cNvGrpSpPr/>
+        <p:nvPr/>
+      </p:nvGrpSpPr>
+      <p:grpSpPr>
+        <a:xfrm>
+          <a:off x="0" y="0"/>
+          <a:ext cx="0" cy="0"/>
+          <a:chOff x="0" y="0"/>
+          <a:chExt cx="0" cy="0"/>
+        </a:xfrm>
+      </p:grpSpPr>
+      <p:sp>
+        <p:nvSpPr>
+          <p:cNvPr id="2" name="Slide Image Placeholder 1"/>
+          <p:cNvSpPr>
+            <a:spLocks noGrp="1"/>
+          </p:cNvSpPr>
+          <p:nvPr>
+            <p:ph type="sldImg" idx="2"/>
+          </p:nvPr>
+        </p:nvSpPr>
+        <p:spPr/>
+      </p:sp>
+      <p:sp>
+        <p:nvSpPr>
+          <p:cNvPr id="3" name="Notes Placeholder 2"/>
+          <p:cNvSpPr>
+            <a:spLocks noGrp="1"/>
+          </p:cNvSpPr>
+          <p:nvPr>
+            <p:ph type="body" idx="1"/>
+          </p:nvPr>
+        </p:nvSpPr>
+        <p:spPr/>
+        <p:txBody>
+          <a:bodyPr/>
+          <a:lstStyle/>
+          <a:p>
+            <a:r>
+              <a:t>Talking points:</a:t>
+            </a:r>
+          </a:p>
+          <a:p>
+            <a:r>
+              <a:t>- A grid: compute the cell, however many cells there are</a:t>
+            </a:r>
+          </a:p>
+          <a:p>
+            <a:r>
+              <a:t>- Separate objects (seed packets, sun): check each one</a:t>
+            </a:r>
+          </a:p>
+          <a:p>
+            <a:r>
+              <a:t>  - Inside its rectangle? Within its radius?</a:t>
+            </a:r>
+          </a:p>
+          <a:p>
+            <a:r>
+              <a:t>- When things overlap, the order of the checks decides</a:t>
+            </a:r>
+          </a:p>
+          <a:p>
+            <a:r>
+              <a:t>  - Sun first, then the seed packets, then the lawn</a:t>
+            </a:r>
+          </a:p>
+          <a:p>
+            <a:r>
+              <a:t>- Show what a click will do: highlight the cell, and a faint plant</a:t>
+            </a:r>
+          </a:p>
+        </p:txBody>
+      </p:sp>
+    </p:spTree>
+  </p:cSld>
+  <p:clrMapOvr>
+    <a:masterClrMapping/>
+  </p:clrMapOvr>
+</p:notes>
+</file>
+
+<file path=ppt/notesSlides/notesSlide8.xml><?xml version="1.0" encoding="utf-8"?>
+<p:notes xmlns:a="http://schemas.openxmlformats.org/drawingml/2006/main" xmlns:p="http://schemas.openxmlformats.org/presentationml/2006/main" xmlns:r="http://schemas.openxmlformats.org/officeDocument/2006/relationships">
+  <p:cSld>
+    <p:spTree>
+      <p:nvGrpSpPr>
+        <p:cNvPr id="1" name=""/>
+        <p:cNvGrpSpPr/>
+        <p:nvPr/>
+      </p:nvGrpSpPr>
+      <p:grpSpPr>
+        <a:xfrm>
+          <a:off x="0" y="0"/>
+          <a:ext cx="0" cy="0"/>
+          <a:chOff x="0" y="0"/>
+          <a:chExt cx="0" cy="0"/>
+        </a:xfrm>
+      </p:grpSpPr>
+      <p:sp>
+        <p:nvSpPr>
+          <p:cNvPr id="2" name="Slide Image Placeholder 1"/>
+          <p:cNvSpPr>
+            <a:spLocks noGrp="1"/>
+          </p:cNvSpPr>
+          <p:nvPr>
+            <p:ph type="sldImg" idx="2"/>
+          </p:nvPr>
+        </p:nvSpPr>
+        <p:spPr/>
+      </p:sp>
+      <p:sp>
+        <p:nvSpPr>
+          <p:cNvPr id="3" name="Notes Placeholder 2"/>
+          <p:cNvSpPr>
+            <a:spLocks noGrp="1"/>
+          </p:cNvSpPr>
+          <p:nvPr>
+            <p:ph type="body" idx="1"/>
+          </p:nvPr>
+        </p:nvSpPr>
+        <p:spPr/>
+        <p:txBody>
+          <a:bodyPr/>
+          <a:lstStyle/>
+          <a:p>
+            <a:r>
+              <a:t>Talking points:</a:t>
+            </a:r>
+          </a:p>
+          <a:p>
+            <a:r>
+              <a:t>- A class per kind of thing</a:t>
+            </a:r>
+          </a:p>
+          <a:p>
+            <a:r>
+              <a:t>  - Plant → Sunflower, Peashooter, WallNut</a:t>
+            </a:r>
+          </a:p>
+          <a:p>
+            <a:r>
+              <a:t>  - Zombie, Pea, Sun</a:t>
+            </a:r>
+          </a:p>
+          <a:p>
+            <a:r>
+              <a:t>- World: one list per class</a:t>
+            </a:r>
+          </a:p>
+          <a:p>
+            <a:r>
+              <a:t>- It works</a:t>
+            </a:r>
+          </a:p>
+        </p:txBody>
+      </p:sp>
+    </p:spTree>
+  </p:cSld>
+  <p:clrMapOvr>
+    <a:masterClrMapping/>
+  </p:clrMapOvr>
+</p:notes>
+</file>
+
+<file path=ppt/notesSlides/notesSlide9.xml><?xml version="1.0" encoding="utf-8"?>
+<p:notes xmlns:a="http://schemas.openxmlformats.org/drawingml/2006/main" xmlns:p="http://schemas.openxmlformats.org/presentationml/2006/main" xmlns:r="http://schemas.openxmlformats.org/officeDocument/2006/relationships">
+  <p:cSld>
+    <p:spTree>
+      <p:nvGrpSpPr>
+        <p:cNvPr id="1" name=""/>
+        <p:cNvGrpSpPr/>
+        <p:nvPr/>
+      </p:nvGrpSpPr>
+      <p:grpSpPr>
+        <a:xfrm>
+          <a:off x="0" y="0"/>
+          <a:ext cx="0" cy="0"/>
+          <a:chOff x="0" y="0"/>
+          <a:chExt cx="0" cy="0"/>
+        </a:xfrm>
+      </p:grpSpPr>
+      <p:sp>
+        <p:nvSpPr>
+          <p:cNvPr id="2" name="Slide Image Placeholder 1"/>
+          <p:cNvSpPr>
+            <a:spLocks noGrp="1"/>
+          </p:cNvSpPr>
+          <p:nvPr>
+            <p:ph type="sldImg" idx="2"/>
+          </p:nvPr>
+        </p:nvSpPr>
+        <p:spPr/>
+      </p:sp>
+      <p:sp>
+        <p:nvSpPr>
+          <p:cNvPr id="3" name="Notes Placeholder 2"/>
+          <p:cNvSpPr>
+            <a:spLocks noGrp="1"/>
+          </p:cNvSpPr>
+          <p:nvPr>
+            <p:ph type="body" idx="1"/>
+          </p:nvPr>
+        </p:nvSpPr>
+        <p:spPr/>
+        <p:txBody>
+          <a:bodyPr/>
+          <a:lstStyle/>
+          <a:p>
+            <a:r>
+              <a:t>Talking points:</a:t>
+            </a:r>
+          </a:p>
+          <a:p>
+            <a:r>
+              <a:t>- A Repeater: a Peashooter subclass that overrides… what?</a:t>
+            </a:r>
+          </a:p>
+          <a:p>
+            <a:r>
+              <a:t>- A Conehead: a Zombie subclass. A plant with armour: copy it</a:t>
+            </a:r>
+          </a:p>
+          <a:p>
+            <a:r>
+              <a:t>- A plant that shoots and makes sun: which parent?</a:t>
+            </a:r>
+          </a:p>
+          <a:p>
+            <a:r>
+              <a:t>  - C# allows one base class: copy the other ability</a:t>
+            </a:r>
+          </a:p>
+          <a:p>
+            <a:r>
+              <a:t>- Health is already copied: a zombie isn’t a plant</a:t>
+            </a:r>
+          </a:p>
+          <a:p>
+            <a:r>
+              <a:t>- Inheritance says what something is; here, what matters is what it can do</a:t>
+            </a:r>
           </a:p>
         </p:txBody>
       </p:sp>
@@ -7631,7 +8155,7 @@
         <p:spPr>
           <a:xfrm>
             <a:off x="311700" y="885950"/>
-            <a:ext cx="8520600" cy="4023300"/>
+            <a:ext cx="8520600" cy="521208"/>
           </a:xfrm>
           <a:prstGeom prst="rect">
             <a:avLst/>
@@ -7655,111 +8179,273 @@
             </a:pPr>
             <a:r>
               <a:rPr lang="en"/>
-              <a:t>Finding each other takes code</a:t>
+              <a:t>Components aren’t free.</a:t>
             </a:r>
             <a:endParaRPr/>
           </a:p>
-          <a:p>
-            <a:pPr indent="-317500" lvl="1" marL="914400" rtl="0" algn="l">
-              <a:spcBef>
-                <a:spcPts val="0"/>
-              </a:spcBef>
-              <a:spcAft>
-                <a:spcPts val="0"/>
-              </a:spcAft>
-              <a:buSzPts val="1400"/>
-              <a:buChar char="○"/>
-            </a:pPr>
-            <a:r>
-              <a:rPr lang="en"/>
-              <a:t>Get&lt;Eater&gt;() searches a list, and may return null</a:t>
-            </a:r>
-            <a:endParaRPr/>
-          </a:p>
-          <a:p>
-            <a:pPr indent="-330200" lvl="0" marL="457200" rtl="0" algn="l">
-              <a:spcBef>
-                <a:spcPts val="0"/>
-              </a:spcBef>
-              <a:spcAft>
-                <a:spcPts val="0"/>
-              </a:spcAft>
-              <a:buSzPts val="1600"/>
-              <a:buChar char="●"/>
-            </a:pPr>
-            <a:r>
-              <a:rPr lang="en"/>
+        </p:txBody>
+      </p:sp>
+      <p:sp>
+        <p:nvSpPr>
+          <p:cNvPr id="295" name="Rounded Rectangle 294"/>
+          <p:cNvSpPr/>
+          <p:nvPr/>
+        </p:nvSpPr>
+        <p:spPr>
+          <a:xfrm>
+            <a:off x="411480" y="1463040"/>
+            <a:ext cx="2651760" cy="1188720"/>
+          </a:xfrm>
+          <a:prstGeom prst="roundRect">
+            <a:avLst>
+              <a:gd name="adj" fmla="val 12000"/>
+            </a:avLst>
+          </a:prstGeom>
+          <a:solidFill>
+            <a:srgbClr val="2E3338"/>
+          </a:solidFill>
+          <a:ln>
+            <a:noFill/>
+          </a:ln>
+          <a:effectLst/>
+        </p:spPr>
+        <p:style>
+          <a:lnRef idx="1">
+            <a:schemeClr val="accent1"/>
+          </a:lnRef>
+          <a:fillRef idx="3">
+            <a:schemeClr val="accent1"/>
+          </a:fillRef>
+          <a:effectRef idx="2">
+            <a:schemeClr val="accent1"/>
+          </a:effectRef>
+          <a:fontRef idx="minor">
+            <a:schemeClr val="lt1"/>
+          </a:fontRef>
+        </p:style>
+        <p:txBody>
+          <a:bodyPr rtlCol="0" anchor="ctr" wrap="square" lIns="73152" rIns="73152"/>
+          <a:lstStyle/>
+          <a:p>
+            <a:pPr algn="ctr"/>
+            <a:r>
+              <a:rPr sz="1500" b="1">
+                <a:solidFill>
+                  <a:srgbClr val="DEE2E6"/>
+                </a:solidFill>
+              </a:rPr>
+              <a:t>Finding each other</a:t>
+            </a:r>
+          </a:p>
+          <a:p>
+            <a:pPr algn="ctr"/>
+            <a:r>
+              <a:rPr sz="1300" b="0">
+                <a:solidFill>
+                  <a:srgbClr val="9AA3AB"/>
+                </a:solidFill>
+              </a:rPr>
+              <a:t>Get&lt;Eater&gt;() searches a list,</a:t>
+            </a:r>
+          </a:p>
+          <a:p>
+            <a:pPr algn="ctr"/>
+            <a:r>
+              <a:rPr sz="1300" b="0">
+                <a:solidFill>
+                  <a:srgbClr val="9AA3AB"/>
+                </a:solidFill>
+              </a:rPr>
+              <a:t>and may return null</a:t>
+            </a:r>
+          </a:p>
+        </p:txBody>
+      </p:sp>
+      <p:sp>
+        <p:nvSpPr>
+          <p:cNvPr id="296" name="Rounded Rectangle 295"/>
+          <p:cNvSpPr/>
+          <p:nvPr/>
+        </p:nvSpPr>
+        <p:spPr>
+          <a:xfrm>
+            <a:off x="3246120" y="1463040"/>
+            <a:ext cx="2651760" cy="1188720"/>
+          </a:xfrm>
+          <a:prstGeom prst="roundRect">
+            <a:avLst>
+              <a:gd name="adj" fmla="val 12000"/>
+            </a:avLst>
+          </a:prstGeom>
+          <a:solidFill>
+            <a:srgbClr val="2E3338"/>
+          </a:solidFill>
+          <a:ln>
+            <a:noFill/>
+          </a:ln>
+          <a:effectLst/>
+        </p:spPr>
+        <p:style>
+          <a:lnRef idx="1">
+            <a:schemeClr val="accent1"/>
+          </a:lnRef>
+          <a:fillRef idx="3">
+            <a:schemeClr val="accent1"/>
+          </a:fillRef>
+          <a:effectRef idx="2">
+            <a:schemeClr val="accent1"/>
+          </a:effectRef>
+          <a:fontRef idx="minor">
+            <a:schemeClr val="lt1"/>
+          </a:fontRef>
+        </p:style>
+        <p:txBody>
+          <a:bodyPr rtlCol="0" anchor="ctr" wrap="square" lIns="73152" rIns="73152"/>
+          <a:lstStyle/>
+          <a:p>
+            <a:pPr algn="ctr"/>
+            <a:r>
+              <a:rPr sz="1500" b="1">
+                <a:solidFill>
+                  <a:srgbClr val="DEE2E6"/>
+                </a:solidFill>
+              </a:rPr>
               <a:t>Order matters</a:t>
             </a:r>
-            <a:endParaRPr/>
-          </a:p>
-          <a:p>
-            <a:pPr indent="-317500" lvl="1" marL="914400" rtl="0" algn="l">
-              <a:spcBef>
-                <a:spcPts val="0"/>
-              </a:spcBef>
-              <a:spcAft>
-                <a:spcPts val="0"/>
-              </a:spcAft>
-              <a:buSzPts val="1400"/>
-              <a:buChar char="○"/>
-            </a:pPr>
-            <a:r>
-              <a:rPr lang="en"/>
-              <a:t>Components update and draw in the order they were added</a:t>
-            </a:r>
-            <a:endParaRPr/>
-          </a:p>
-          <a:p>
-            <a:pPr indent="-330200" lvl="0" marL="457200" rtl="0" algn="l">
-              <a:spcBef>
-                <a:spcPts val="0"/>
-              </a:spcBef>
-              <a:spcAft>
-                <a:spcPts val="0"/>
-              </a:spcAft>
-              <a:buSzPts val="1600"/>
-              <a:buChar char="●"/>
-            </a:pPr>
-            <a:r>
-              <a:rPr lang="en"/>
+          </a:p>
+          <a:p>
+            <a:pPr algn="ctr"/>
+            <a:r>
+              <a:rPr sz="1300" b="0">
+                <a:solidFill>
+                  <a:srgbClr val="9AA3AB"/>
+                </a:solidFill>
+              </a:rPr>
+              <a:t>components update and draw</a:t>
+            </a:r>
+          </a:p>
+          <a:p>
+            <a:pPr algn="ctr"/>
+            <a:r>
+              <a:rPr sz="1300" b="0">
+                <a:solidFill>
+                  <a:srgbClr val="9AA3AB"/>
+                </a:solidFill>
+              </a:rPr>
+              <a:t>in the order they were added</a:t>
+            </a:r>
+          </a:p>
+        </p:txBody>
+      </p:sp>
+      <p:sp>
+        <p:nvSpPr>
+          <p:cNvPr id="297" name="Rounded Rectangle 296"/>
+          <p:cNvSpPr/>
+          <p:nvPr/>
+        </p:nvSpPr>
+        <p:spPr>
+          <a:xfrm>
+            <a:off x="6080760" y="1463040"/>
+            <a:ext cx="2651760" cy="1188720"/>
+          </a:xfrm>
+          <a:prstGeom prst="roundRect">
+            <a:avLst>
+              <a:gd name="adj" fmla="val 12000"/>
+            </a:avLst>
+          </a:prstGeom>
+          <a:solidFill>
+            <a:srgbClr val="2E3338"/>
+          </a:solidFill>
+          <a:ln w="25400">
+            <a:solidFill>
+              <a:srgbClr val="D45D35"/>
+            </a:solidFill>
+          </a:ln>
+          <a:effectLst/>
+        </p:spPr>
+        <p:style>
+          <a:lnRef idx="1">
+            <a:schemeClr val="accent1"/>
+          </a:lnRef>
+          <a:fillRef idx="3">
+            <a:schemeClr val="accent1"/>
+          </a:fillRef>
+          <a:effectRef idx="2">
+            <a:schemeClr val="accent1"/>
+          </a:effectRef>
+          <a:fontRef idx="minor">
+            <a:schemeClr val="lt1"/>
+          </a:fontRef>
+        </p:style>
+        <p:txBody>
+          <a:bodyPr rtlCol="0" anchor="ctr" wrap="square" lIns="73152" rIns="73152"/>
+          <a:lstStyle/>
+          <a:p>
+            <a:pPr algn="ctr"/>
+            <a:r>
+              <a:rPr sz="1500" b="1">
+                <a:solidFill>
+                  <a:srgbClr val="DEE2E6"/>
+                </a:solidFill>
+              </a:rPr>
               <a:t>Where does a rule go?</a:t>
             </a:r>
-            <a:endParaRPr/>
-          </a:p>
-          <a:p>
-            <a:pPr indent="-317500" lvl="1" marL="914400" rtl="0" algn="l">
-              <a:spcBef>
-                <a:spcPts val="0"/>
-              </a:spcBef>
-              <a:spcAft>
-                <a:spcPts val="0"/>
-              </a:spcAft>
-              <a:buSzPts val="1400"/>
-              <a:buChar char="○"/>
-            </a:pPr>
-            <a:r>
-              <a:rPr lang="en"/>
-              <a:t>A pea hits a zombie: the pea’s rule, or the zombie’s?</a:t>
-            </a:r>
-            <a:endParaRPr/>
-          </a:p>
-          <a:p>
-            <a:pPr indent="-317500" lvl="1" marL="914400" rtl="0" algn="l">
-              <a:spcBef>
-                <a:spcPts val="0"/>
-              </a:spcBef>
-              <a:spcAft>
-                <a:spcPts val="0"/>
-              </a:spcAft>
-              <a:buSzPts val="1400"/>
-              <a:buChar char="○"/>
-            </a:pPr>
-            <a:r>
-              <a:rPr lang="en"/>
-              <a:t>Geometry Wars moves such rules into systems</a:t>
-            </a:r>
-            <a:endParaRPr/>
+          </a:p>
+          <a:p>
+            <a:pPr algn="ctr"/>
+            <a:r>
+              <a:rPr sz="1300" b="0">
+                <a:solidFill>
+                  <a:srgbClr val="9AA3AB"/>
+                </a:solidFill>
+              </a:rPr>
+              <a:t>a pea hits a zombie:</a:t>
+            </a:r>
+          </a:p>
+          <a:p>
+            <a:pPr algn="ctr"/>
+            <a:r>
+              <a:rPr sz="1300" b="0">
+                <a:solidFill>
+                  <a:srgbClr val="9AA3AB"/>
+                </a:solidFill>
+              </a:rPr>
+              <a:t>the pea’s rule, or the zombie’s?</a:t>
+            </a:r>
+          </a:p>
+        </p:txBody>
+      </p:sp>
+      <p:sp>
+        <p:nvSpPr>
+          <p:cNvPr id="298" name="TextBox 297"/>
+          <p:cNvSpPr txBox="1"/>
+          <p:nvPr/>
+        </p:nvSpPr>
+        <p:spPr>
+          <a:xfrm>
+            <a:off x="411480" y="2926080"/>
+            <a:ext cx="8321040" cy="365760"/>
+          </a:xfrm>
+          <a:prstGeom prst="rect">
+            <a:avLst/>
+          </a:prstGeom>
+          <a:noFill/>
+        </p:spPr>
+        <p:txBody>
+          <a:bodyPr wrap="square">
+            <a:spAutoFit/>
+          </a:bodyPr>
+          <a:lstStyle/>
+          <a:p>
+            <a:pPr algn="ctr"/>
+            <a:r>
+              <a:rPr sz="1400" b="0" i="0">
+                <a:solidFill>
+                  <a:srgbClr val="9AA3AB"/>
+                </a:solidFill>
+              </a:rPr>
+              <a:t>Geometry Wars moves rules like that into systems.</a:t>
+            </a:r>
           </a:p>
         </p:txBody>
       </p:sp>
@@ -9521,7 +10207,7 @@
         <p:spPr>
           <a:xfrm>
             <a:off x="311700" y="885950"/>
-            <a:ext cx="8520600" cy="4023300"/>
+            <a:ext cx="8520600" cy="521208"/>
           </a:xfrm>
           <a:prstGeom prst="rect">
             <a:avLst/>
@@ -9545,111 +10231,219 @@
             </a:pPr>
             <a:r>
               <a:rPr lang="en"/>
-              <a:t>Prototype (Angry Birds): copy a configured object</a:t>
+              <a:t>Two ways to make many things of one kind.</a:t>
             </a:r>
             <a:endParaRPr/>
           </a:p>
-          <a:p>
-            <a:pPr indent="-317500" lvl="1" marL="914400" rtl="0" algn="l">
-              <a:spcBef>
-                <a:spcPts val="0"/>
-              </a:spcBef>
-              <a:spcAft>
-                <a:spcPts val="0"/>
-              </a:spcAft>
-              <a:buSzPts val="1400"/>
-              <a:buChar char="○"/>
-            </a:pPr>
-            <a:r>
-              <a:rPr lang="en"/>
-              <a:t>Shared data is copied into every clone</a:t>
-            </a:r>
-            <a:endParaRPr/>
-          </a:p>
-          <a:p>
-            <a:pPr indent="-317500" lvl="1" marL="914400" rtl="0" algn="l">
-              <a:spcBef>
-                <a:spcPts val="0"/>
-              </a:spcBef>
-              <a:spcAft>
-                <a:spcPts val="0"/>
-              </a:spcAft>
-              <a:buSzPts val="1400"/>
-              <a:buChar char="○"/>
-            </a:pPr>
-            <a:r>
-              <a:rPr lang="en"/>
-              <a:t>Good for “make more like this one”</a:t>
-            </a:r>
-            <a:endParaRPr/>
-          </a:p>
-          <a:p>
-            <a:pPr indent="-330200" lvl="0" marL="457200" rtl="0" algn="l">
-              <a:spcBef>
-                <a:spcPts val="0"/>
-              </a:spcBef>
-              <a:spcAft>
-                <a:spcPts val="0"/>
-              </a:spcAft>
-              <a:buSzPts val="1600"/>
-              <a:buChar char="●"/>
-            </a:pPr>
-            <a:r>
-              <a:rPr lang="en"/>
-              <a:t>Type Object: a separate type class creates instances</a:t>
-            </a:r>
-            <a:endParaRPr/>
-          </a:p>
-          <a:p>
-            <a:pPr indent="-317500" lvl="1" marL="914400" rtl="0" algn="l">
-              <a:spcBef>
-                <a:spcPts val="0"/>
-              </a:spcBef>
-              <a:spcAft>
-                <a:spcPts val="0"/>
-              </a:spcAft>
-              <a:buSzPts val="1400"/>
-              <a:buChar char="○"/>
-            </a:pPr>
-            <a:r>
-              <a:rPr lang="en"/>
-              <a:t>Shared data is kept once, in the type</a:t>
-            </a:r>
-            <a:endParaRPr/>
-          </a:p>
-          <a:p>
-            <a:pPr indent="-317500" lvl="1" marL="914400" rtl="0" algn="l">
-              <a:spcBef>
-                <a:spcPts val="0"/>
-              </a:spcBef>
-              <a:spcAft>
-                <a:spcPts val="0"/>
-              </a:spcAft>
-              <a:buSzPts val="1400"/>
-              <a:buChar char="○"/>
-            </a:pPr>
-            <a:r>
-              <a:rPr lang="en"/>
-              <a:t>An instance can refer to its type</a:t>
-            </a:r>
-            <a:endParaRPr/>
-          </a:p>
-          <a:p>
-            <a:pPr indent="-317500" lvl="1" marL="914400" rtl="0" algn="l">
-              <a:spcBef>
-                <a:spcPts val="0"/>
-              </a:spcBef>
-              <a:spcAft>
-                <a:spcPts val="0"/>
-              </a:spcAft>
-              <a:buSzPts val="1400"/>
-              <a:buChar char="○"/>
-            </a:pPr>
-            <a:r>
-              <a:rPr lang="en"/>
-              <a:t>Good for kinds with their own data and rules</a:t>
-            </a:r>
-            <a:endParaRPr/>
+        </p:txBody>
+      </p:sp>
+      <p:sp>
+        <p:nvSpPr>
+          <p:cNvPr id="295" name="Rounded Rectangle 294"/>
+          <p:cNvSpPr/>
+          <p:nvPr/>
+        </p:nvSpPr>
+        <p:spPr>
+          <a:xfrm>
+            <a:off x="548640" y="1417320"/>
+            <a:ext cx="3749039" cy="1463040"/>
+          </a:xfrm>
+          <a:prstGeom prst="roundRect">
+            <a:avLst>
+              <a:gd name="adj" fmla="val 12000"/>
+            </a:avLst>
+          </a:prstGeom>
+          <a:solidFill>
+            <a:srgbClr val="2E3338"/>
+          </a:solidFill>
+          <a:ln>
+            <a:noFill/>
+          </a:ln>
+          <a:effectLst/>
+        </p:spPr>
+        <p:style>
+          <a:lnRef idx="1">
+            <a:schemeClr val="accent1"/>
+          </a:lnRef>
+          <a:fillRef idx="3">
+            <a:schemeClr val="accent1"/>
+          </a:fillRef>
+          <a:effectRef idx="2">
+            <a:schemeClr val="accent1"/>
+          </a:effectRef>
+          <a:fontRef idx="minor">
+            <a:schemeClr val="lt1"/>
+          </a:fontRef>
+        </p:style>
+        <p:txBody>
+          <a:bodyPr rtlCol="0" anchor="ctr" wrap="square" lIns="73152" rIns="73152"/>
+          <a:lstStyle/>
+          <a:p>
+            <a:pPr algn="ctr"/>
+            <a:r>
+              <a:rPr sz="1500" b="1">
+                <a:solidFill>
+                  <a:srgbClr val="DEE2E6"/>
+                </a:solidFill>
+              </a:rPr>
+              <a:t>Prototype (Angry Birds)</a:t>
+            </a:r>
+          </a:p>
+          <a:p>
+            <a:pPr algn="ctr"/>
+            <a:r>
+              <a:rPr sz="1300" b="0">
+                <a:solidFill>
+                  <a:srgbClr val="9AA3AB"/>
+                </a:solidFill>
+              </a:rPr>
+              <a:t>copy a configured object;</a:t>
+            </a:r>
+          </a:p>
+          <a:p>
+            <a:pPr algn="ctr"/>
+            <a:r>
+              <a:rPr sz="1300" b="0">
+                <a:solidFill>
+                  <a:srgbClr val="9AA3AB"/>
+                </a:solidFill>
+              </a:rPr>
+              <a:t>shared data is copied into each clone</a:t>
+            </a:r>
+          </a:p>
+          <a:p>
+            <a:pPr algn="ctr"/>
+            <a:r>
+              <a:rPr sz="1300" b="0">
+                <a:solidFill>
+                  <a:srgbClr val="9AA3AB"/>
+                </a:solidFill>
+              </a:rPr>
+              <a:t>“more like this one”</a:t>
+            </a:r>
+          </a:p>
+        </p:txBody>
+      </p:sp>
+      <p:sp>
+        <p:nvSpPr>
+          <p:cNvPr id="296" name="Rounded Rectangle 295"/>
+          <p:cNvSpPr/>
+          <p:nvPr/>
+        </p:nvSpPr>
+        <p:spPr>
+          <a:xfrm>
+            <a:off x="4846320" y="1417320"/>
+            <a:ext cx="3749039" cy="1463040"/>
+          </a:xfrm>
+          <a:prstGeom prst="roundRect">
+            <a:avLst>
+              <a:gd name="adj" fmla="val 12000"/>
+            </a:avLst>
+          </a:prstGeom>
+          <a:solidFill>
+            <a:srgbClr val="2E3338"/>
+          </a:solidFill>
+          <a:ln w="25400">
+            <a:solidFill>
+              <a:srgbClr val="D45D35"/>
+            </a:solidFill>
+          </a:ln>
+          <a:effectLst/>
+        </p:spPr>
+        <p:style>
+          <a:lnRef idx="1">
+            <a:schemeClr val="accent1"/>
+          </a:lnRef>
+          <a:fillRef idx="3">
+            <a:schemeClr val="accent1"/>
+          </a:fillRef>
+          <a:effectRef idx="2">
+            <a:schemeClr val="accent1"/>
+          </a:effectRef>
+          <a:fontRef idx="minor">
+            <a:schemeClr val="lt1"/>
+          </a:fontRef>
+        </p:style>
+        <p:txBody>
+          <a:bodyPr rtlCol="0" anchor="ctr" wrap="square" lIns="73152" rIns="73152"/>
+          <a:lstStyle/>
+          <a:p>
+            <a:pPr algn="ctr"/>
+            <a:r>
+              <a:rPr sz="1500" b="1">
+                <a:solidFill>
+                  <a:srgbClr val="DEE2E6"/>
+                </a:solidFill>
+              </a:rPr>
+              <a:t>Type Object (here)</a:t>
+            </a:r>
+          </a:p>
+          <a:p>
+            <a:pPr algn="ctr"/>
+            <a:r>
+              <a:rPr sz="1300" b="0">
+                <a:solidFill>
+                  <a:srgbClr val="9AA3AB"/>
+                </a:solidFill>
+              </a:rPr>
+              <a:t>a type class creates instances;</a:t>
+            </a:r>
+          </a:p>
+          <a:p>
+            <a:pPr algn="ctr"/>
+            <a:r>
+              <a:rPr sz="1300" b="0">
+                <a:solidFill>
+                  <a:srgbClr val="9AA3AB"/>
+                </a:solidFill>
+              </a:rPr>
+              <a:t>shared data is kept once, in the type</a:t>
+            </a:r>
+          </a:p>
+          <a:p>
+            <a:pPr algn="ctr"/>
+            <a:r>
+              <a:rPr sz="1300" b="0">
+                <a:solidFill>
+                  <a:srgbClr val="9AA3AB"/>
+                </a:solidFill>
+              </a:rPr>
+              <a:t>kinds with their own data and rules</a:t>
+            </a:r>
+          </a:p>
+        </p:txBody>
+      </p:sp>
+      <p:sp>
+        <p:nvSpPr>
+          <p:cNvPr id="297" name="TextBox 296"/>
+          <p:cNvSpPr txBox="1"/>
+          <p:nvPr/>
+        </p:nvSpPr>
+        <p:spPr>
+          <a:xfrm>
+            <a:off x="457200" y="3154680"/>
+            <a:ext cx="8229600" cy="731520"/>
+          </a:xfrm>
+          <a:prstGeom prst="rect">
+            <a:avLst/>
+          </a:prstGeom>
+          <a:noFill/>
+        </p:spPr>
+        <p:txBody>
+          <a:bodyPr wrap="square">
+            <a:spAutoFit/>
+          </a:bodyPr>
+          <a:lstStyle/>
+          <a:p>
+            <a:pPr algn="ctr"/>
+            <a:r>
+              <a:rPr sz="1600" b="1" i="0">
+                <a:solidFill>
+                  <a:srgbClr val="DEE2E6"/>
+                </a:solidFill>
+              </a:rPr>
+              <a:t>A plant’s cost: in each plant, or in its type?</a:t>
+            </a:r>
           </a:p>
         </p:txBody>
       </p:sp>
@@ -12890,6 +13684,179 @@
 </p:sld>
 </file>
 
+<file path=ppt/slides/slide26.xml><?xml version="1.0" encoding="utf-8"?>
+<p:sld xmlns:a="http://schemas.openxmlformats.org/drawingml/2006/main" xmlns:p="http://schemas.openxmlformats.org/presentationml/2006/main" xmlns:r="http://schemas.openxmlformats.org/officeDocument/2006/relationships">
+  <p:cSld>
+    <p:spTree>
+      <p:nvGrpSpPr>
+        <p:cNvPr id="1" name=""/>
+        <p:cNvGrpSpPr/>
+        <p:nvPr/>
+      </p:nvGrpSpPr>
+      <p:grpSpPr/>
+      <p:sp>
+        <p:nvSpPr>
+          <p:cNvPr id="2" name="Title 1"/>
+          <p:cNvSpPr>
+            <a:spLocks noGrp="1"/>
+          </p:cNvSpPr>
+          <p:nvPr>
+            <p:ph type="title"/>
+          </p:nvPr>
+        </p:nvSpPr>
+        <p:spPr/>
+        <p:txBody>
+          <a:bodyPr/>
+          <a:lstStyle/>
+          <a:p>
+            <a:pPr indent="0" lvl="0" marL="0" rtl="0" algn="l">
+              <a:spcBef>
+                <a:spcPts val="0"/>
+              </a:spcBef>
+              <a:spcAft>
+                <a:spcPts val="0"/>
+              </a:spcAft>
+              <a:buNone/>
+            </a:pPr>
+            <a:r>
+              <a:rPr lang="en"/>
+              <a:t>Check Yourself</a:t>
+            </a:r>
+            <a:endParaRPr/>
+          </a:p>
+        </p:txBody>
+      </p:sp>
+      <p:sp>
+        <p:nvSpPr>
+          <p:cNvPr id="3" name="Text Placeholder 2"/>
+          <p:cNvSpPr>
+            <a:spLocks noGrp="1"/>
+          </p:cNvSpPr>
+          <p:nvPr>
+            <p:ph type="body" idx="1"/>
+          </p:nvPr>
+        </p:nvSpPr>
+        <p:spPr>
+          <a:xfrm>
+            <a:off x="311700" y="885950"/>
+            <a:ext cx="8520600" cy="1719072"/>
+          </a:xfrm>
+        </p:spPr>
+        <p:txBody>
+          <a:bodyPr/>
+          <a:lstStyle/>
+          <a:p>
+            <a:pPr indent="-330200" lvl="0" marL="457200" rtl="0" algn="l">
+              <a:spcBef>
+                <a:spcPts val="0"/>
+              </a:spcBef>
+              <a:spcAft>
+                <a:spcPts val="0"/>
+              </a:spcAft>
+              <a:buSzPts val="1600"/>
+              <a:buChar char="●"/>
+            </a:pPr>
+            <a:r>
+              <a:rPr lang="en"/>
+              <a:t>Why does inheritance break down for Plants vs. Zombies?</a:t>
+            </a:r>
+            <a:endParaRPr/>
+          </a:p>
+          <a:p>
+            <a:pPr indent="-330200" lvl="0" marL="457200" rtl="0" algn="l">
+              <a:spcBef>
+                <a:spcPts val="0"/>
+              </a:spcBef>
+              <a:spcAft>
+                <a:spcPts val="0"/>
+              </a:spcAft>
+              <a:buSzPts val="1600"/>
+              <a:buChar char="●"/>
+            </a:pPr>
+            <a:r>
+              <a:rPr lang="en"/>
+              <a:t>How do components in one entity work together without knowing each other’s classes?</a:t>
+            </a:r>
+            <a:endParaRPr/>
+          </a:p>
+          <a:p>
+            <a:pPr indent="-330200" lvl="0" marL="457200" rtl="0" algn="l">
+              <a:spcBef>
+                <a:spcPts val="0"/>
+              </a:spcBef>
+              <a:spcAft>
+                <a:spcPts val="0"/>
+              </a:spcAft>
+              <a:buSzPts val="1600"/>
+              <a:buChar char="●"/>
+            </a:pPr>
+            <a:r>
+              <a:rPr lang="en"/>
+              <a:t>What goes in a type object, and what goes in an instance?</a:t>
+            </a:r>
+            <a:endParaRPr/>
+          </a:p>
+          <a:p>
+            <a:pPr indent="-330200" lvl="0" marL="457200" rtl="0" algn="l">
+              <a:spcBef>
+                <a:spcPts val="0"/>
+              </a:spcBef>
+              <a:spcAft>
+                <a:spcPts val="0"/>
+              </a:spcAft>
+              <a:buSzPts val="1600"/>
+              <a:buChar char="●"/>
+            </a:pPr>
+            <a:r>
+              <a:rPr lang="en"/>
+              <a:t>How is picking on a grid different from picking a list of objects?</a:t>
+            </a:r>
+            <a:endParaRPr/>
+          </a:p>
+        </p:txBody>
+      </p:sp>
+      <p:sp>
+        <p:nvSpPr>
+          <p:cNvPr id="4" name="TextBox 3"/>
+          <p:cNvSpPr txBox="1"/>
+          <p:nvPr/>
+        </p:nvSpPr>
+        <p:spPr>
+          <a:xfrm>
+            <a:off x="457200" y="3182112"/>
+            <a:ext cx="8229600" cy="457200"/>
+          </a:xfrm>
+          <a:prstGeom prst="rect">
+            <a:avLst/>
+          </a:prstGeom>
+          <a:noFill/>
+        </p:spPr>
+        <p:txBody>
+          <a:bodyPr wrap="square">
+            <a:spAutoFit/>
+          </a:bodyPr>
+          <a:lstStyle/>
+          <a:p>
+            <a:pPr algn="ctr"/>
+            <a:r>
+              <a:rPr sz="1400" b="0" i="0">
+                <a:solidFill>
+                  <a:srgbClr val="9AA3AB"/>
+                </a:solidFill>
+              </a:rPr>
+              <a:t>The answers, and more questions, are on the course site.</a:t>
+            </a:r>
+          </a:p>
+        </p:txBody>
+      </p:sp>
+    </p:spTree>
+  </p:cSld>
+  <p:clrMapOvr>
+    <a:masterClrMapping/>
+  </p:clrMapOvr>
+</p:sld>
+</file>
+
 <file path=ppt/slides/slide3.xml><?xml version="1.0" encoding="utf-8"?>
 <p:sld xmlns:a="http://schemas.openxmlformats.org/drawingml/2006/main" xmlns:r="http://schemas.openxmlformats.org/officeDocument/2006/relationships" xmlns:mc="http://schemas.openxmlformats.org/markup-compatibility/2006" xmlns:mv="urn:schemas-microsoft-com:mac:vml" xmlns:p="http://schemas.openxmlformats.org/presentationml/2006/main" xmlns:c="http://schemas.openxmlformats.org/drawingml/2006/chart" xmlns:dgm="http://schemas.openxmlformats.org/drawingml/2006/diagram" xmlns:o="urn:schemas-microsoft-com:office:office" xmlns:v="urn:schemas-microsoft-com:vml" xmlns:pvml="urn:schemas-microsoft-com:office:powerpoint" xmlns:com="http://schemas.openxmlformats.org/drawingml/2006/compatibility" xmlns:p14="http://schemas.microsoft.com/office/powerpoint/2010/main" xmlns:p15="http://schemas.microsoft.com/office/powerpoint/2012/main" xmlns:ahyp="http://schemas.microsoft.com/office/drawing/2018/hyperlinkcolor">
   <p:cSld>
@@ -13424,7 +14391,7 @@
         <p:spPr>
           <a:xfrm>
             <a:off x="311700" y="885950"/>
-            <a:ext cx="8520600" cy="4023300"/>
+            <a:ext cx="8520600" cy="1289304"/>
           </a:xfrm>
           <a:prstGeom prst="rect">
             <a:avLst/>
@@ -13448,29 +14415,7 @@
             </a:pPr>
             <a:r>
               <a:rPr lang="en"/>
-              <a:t>All Source code for today’s game can be found here:</a:t>
-            </a:r>
-            <a:endParaRPr/>
-          </a:p>
-          <a:p>
-            <a:pPr indent="-317500" lvl="1" marL="914400" rtl="0" algn="l">
-              <a:spcBef>
-                <a:spcPts val="0"/>
-              </a:spcBef>
-              <a:spcAft>
-                <a:spcPts val="0"/>
-              </a:spcAft>
-              <a:buSzPts val="1400"/>
-              <a:buChar char="○"/>
-            </a:pPr>
-            <a:r>
-              <a:rPr lang="en" u="sng">
-                <a:solidFill>
-                  <a:schemeClr val="hlink"/>
-                </a:solidFill>
-                <a:hlinkClick r:id="rId3"/>
-              </a:rPr>
-              <a:t>github.com/Metamate/gar-games (folder 09-plants-vs-zombies)</a:t>
+              <a:t>github.com/Metamate/gar-games, folder 09-plants-vs-zombies</a:t>
             </a:r>
             <a:endParaRPr/>
           </a:p>
@@ -13487,41 +14432,7 @@
             </a:pPr>
             <a:r>
               <a:rPr lang="en"/>
-              <a:t>The game is built up in steps: Pvz0 → Pvz4</a:t>
-            </a:r>
-            <a:endParaRPr/>
-          </a:p>
-          <a:p>
-            <a:pPr indent="-317500" lvl="1" marL="914400" rtl="0" algn="l">
-              <a:spcBef>
-                <a:spcPts val="0"/>
-              </a:spcBef>
-              <a:spcAft>
-                <a:spcPts val="0"/>
-              </a:spcAft>
-              <a:buSzPts val="1400"/>
-              <a:buChar char="○"/>
-            </a:pPr>
-            <a:r>
-              <a:rPr lang="en"/>
-              <a:t>Each step is a separate project that adds one concept</a:t>
-            </a:r>
-            <a:endParaRPr/>
-          </a:p>
-          <a:p>
-            <a:pPr indent="-317500" lvl="1" marL="914400" rtl="0" algn="l">
-              <a:spcBef>
-                <a:spcPts val="0"/>
-              </a:spcBef>
-              <a:spcAft>
-                <a:spcPts val="0"/>
-              </a:spcAft>
-              <a:buSzPts val="1400"/>
-              <a:buChar char="○"/>
-            </a:pPr>
-            <a:r>
-              <a:rPr lang="en"/>
-              <a:t>Compare neighbouring steps to see exactly what changed</a:t>
+              <a:t>Its README: the steps (Pvz0 to Pvz4), a map of the code, how to run it</a:t>
             </a:r>
             <a:endParaRPr/>
           </a:p>
@@ -13538,7 +14449,7 @@
             </a:pPr>
             <a:r>
               <a:rPr lang="en"/>
-              <a:t>Pvz4 is the finished game, and the starting point for the exercises</a:t>
+              <a:t>The course site: today’s concepts in full, the exercises, and questions to check yourself</a:t>
             </a:r>
             <a:endParaRPr/>
           </a:p>
@@ -14417,7 +15328,7 @@
         <p:spPr>
           <a:xfrm>
             <a:off x="311700" y="885950"/>
-            <a:ext cx="8520600" cy="4023300"/>
+            <a:ext cx="8520600" cy="521208"/>
           </a:xfrm>
           <a:prstGeom prst="rect">
             <a:avLst/>
@@ -14441,94 +15352,465 @@
             </a:pPr>
             <a:r>
               <a:rPr lang="en"/>
-              <a:t>A grid: compute the cell, however many cells there are</a:t>
+              <a:t>A grid: compute the cell. Separate objects: check each one.</a:t>
             </a:r>
             <a:endParaRPr/>
           </a:p>
-          <a:p>
-            <a:pPr indent="-330200" lvl="0" marL="457200" rtl="0" algn="l">
-              <a:spcBef>
-                <a:spcPts val="0"/>
-              </a:spcBef>
-              <a:spcAft>
-                <a:spcPts val="0"/>
-              </a:spcAft>
-              <a:buSzPts val="1600"/>
-              <a:buChar char="●"/>
-            </a:pPr>
-            <a:r>
-              <a:rPr lang="en"/>
-              <a:t>Separate objects (seed packets, sun): check each one</a:t>
-            </a:r>
-            <a:endParaRPr/>
-          </a:p>
-          <a:p>
-            <a:pPr indent="-317500" lvl="1" marL="914400" rtl="0" algn="l">
-              <a:spcBef>
-                <a:spcPts val="0"/>
-              </a:spcBef>
-              <a:spcAft>
-                <a:spcPts val="0"/>
-              </a:spcAft>
-              <a:buSzPts val="1400"/>
-              <a:buChar char="○"/>
-            </a:pPr>
-            <a:r>
-              <a:rPr lang="en"/>
-              <a:t>Inside its rectangle? Within its radius?</a:t>
-            </a:r>
-            <a:endParaRPr/>
-          </a:p>
-          <a:p>
-            <a:pPr indent="-330200" lvl="0" marL="457200" rtl="0" algn="l">
-              <a:spcBef>
-                <a:spcPts val="0"/>
-              </a:spcBef>
-              <a:spcAft>
-                <a:spcPts val="0"/>
-              </a:spcAft>
-              <a:buSzPts val="1600"/>
-              <a:buChar char="●"/>
-            </a:pPr>
-            <a:r>
-              <a:rPr lang="en"/>
-              <a:t>When things overlap, the order of the checks decides</a:t>
-            </a:r>
-            <a:endParaRPr/>
-          </a:p>
-          <a:p>
-            <a:pPr indent="-317500" lvl="1" marL="914400" rtl="0" algn="l">
-              <a:spcBef>
-                <a:spcPts val="0"/>
-              </a:spcBef>
-              <a:spcAft>
-                <a:spcPts val="0"/>
-              </a:spcAft>
-              <a:buSzPts val="1400"/>
-              <a:buChar char="○"/>
-            </a:pPr>
-            <a:r>
-              <a:rPr lang="en"/>
-              <a:t>Sun first, then the seed packets, then the lawn</a:t>
-            </a:r>
-            <a:endParaRPr/>
-          </a:p>
-          <a:p>
-            <a:pPr indent="-330200" lvl="0" marL="457200" rtl="0" algn="l">
-              <a:spcBef>
-                <a:spcPts val="0"/>
-              </a:spcBef>
-              <a:spcAft>
-                <a:spcPts val="0"/>
-              </a:spcAft>
-              <a:buSzPts val="1600"/>
-              <a:buChar char="●"/>
-            </a:pPr>
-            <a:r>
-              <a:rPr lang="en"/>
-              <a:t>Show what a click will do: highlight the cell, and a faint plant</a:t>
-            </a:r>
-            <a:endParaRPr/>
+        </p:txBody>
+      </p:sp>
+      <p:sp>
+        <p:nvSpPr>
+          <p:cNvPr id="295" name="Rounded Rectangle 294"/>
+          <p:cNvSpPr/>
+          <p:nvPr/>
+        </p:nvSpPr>
+        <p:spPr>
+          <a:xfrm>
+            <a:off x="548640" y="1417320"/>
+            <a:ext cx="3749039" cy="914400"/>
+          </a:xfrm>
+          <a:prstGeom prst="roundRect">
+            <a:avLst>
+              <a:gd name="adj" fmla="val 12000"/>
+            </a:avLst>
+          </a:prstGeom>
+          <a:solidFill>
+            <a:srgbClr val="2E3338"/>
+          </a:solidFill>
+          <a:ln>
+            <a:noFill/>
+          </a:ln>
+          <a:effectLst/>
+        </p:spPr>
+        <p:style>
+          <a:lnRef idx="1">
+            <a:schemeClr val="accent1"/>
+          </a:lnRef>
+          <a:fillRef idx="3">
+            <a:schemeClr val="accent1"/>
+          </a:fillRef>
+          <a:effectRef idx="2">
+            <a:schemeClr val="accent1"/>
+          </a:effectRef>
+          <a:fontRef idx="minor">
+            <a:schemeClr val="lt1"/>
+          </a:fontRef>
+        </p:style>
+        <p:txBody>
+          <a:bodyPr rtlCol="0" anchor="ctr" wrap="square" lIns="73152" rIns="73152"/>
+          <a:lstStyle/>
+          <a:p>
+            <a:pPr algn="ctr"/>
+            <a:r>
+              <a:rPr sz="1500" b="1">
+                <a:solidFill>
+                  <a:srgbClr val="DEE2E6"/>
+                </a:solidFill>
+              </a:rPr>
+              <a:t>The lawn: a grid</a:t>
+            </a:r>
+          </a:p>
+          <a:p>
+            <a:pPr algn="ctr"/>
+            <a:r>
+              <a:rPr sz="1300" b="0">
+                <a:solidFill>
+                  <a:srgbClr val="9AA3AB"/>
+                </a:solidFill>
+              </a:rPr>
+              <a:t>one division finds the cell,</a:t>
+            </a:r>
+          </a:p>
+          <a:p>
+            <a:pPr algn="ctr"/>
+            <a:r>
+              <a:rPr sz="1300" b="0">
+                <a:solidFill>
+                  <a:srgbClr val="9AA3AB"/>
+                </a:solidFill>
+              </a:rPr>
+              <a:t>however many cells</a:t>
+            </a:r>
+          </a:p>
+        </p:txBody>
+      </p:sp>
+      <p:sp>
+        <p:nvSpPr>
+          <p:cNvPr id="296" name="Rounded Rectangle 295"/>
+          <p:cNvSpPr/>
+          <p:nvPr/>
+        </p:nvSpPr>
+        <p:spPr>
+          <a:xfrm>
+            <a:off x="4846320" y="1417320"/>
+            <a:ext cx="3749039" cy="914400"/>
+          </a:xfrm>
+          <a:prstGeom prst="roundRect">
+            <a:avLst>
+              <a:gd name="adj" fmla="val 12000"/>
+            </a:avLst>
+          </a:prstGeom>
+          <a:solidFill>
+            <a:srgbClr val="2E3338"/>
+          </a:solidFill>
+          <a:ln>
+            <a:noFill/>
+          </a:ln>
+          <a:effectLst/>
+        </p:spPr>
+        <p:style>
+          <a:lnRef idx="1">
+            <a:schemeClr val="accent1"/>
+          </a:lnRef>
+          <a:fillRef idx="3">
+            <a:schemeClr val="accent1"/>
+          </a:fillRef>
+          <a:effectRef idx="2">
+            <a:schemeClr val="accent1"/>
+          </a:effectRef>
+          <a:fontRef idx="minor">
+            <a:schemeClr val="lt1"/>
+          </a:fontRef>
+        </p:style>
+        <p:txBody>
+          <a:bodyPr rtlCol="0" anchor="ctr" wrap="square" lIns="73152" rIns="73152"/>
+          <a:lstStyle/>
+          <a:p>
+            <a:pPr algn="ctr"/>
+            <a:r>
+              <a:rPr sz="1500" b="1">
+                <a:solidFill>
+                  <a:srgbClr val="DEE2E6"/>
+                </a:solidFill>
+              </a:rPr>
+              <a:t>Suns, seed packets: objects</a:t>
+            </a:r>
+          </a:p>
+          <a:p>
+            <a:pPr algn="ctr"/>
+            <a:r>
+              <a:rPr sz="1300" b="0">
+                <a:solidFill>
+                  <a:srgbClr val="9AA3AB"/>
+                </a:solidFill>
+              </a:rPr>
+              <a:t>inside its rectangle?</a:t>
+            </a:r>
+          </a:p>
+          <a:p>
+            <a:pPr algn="ctr"/>
+            <a:r>
+              <a:rPr sz="1300" b="0">
+                <a:solidFill>
+                  <a:srgbClr val="9AA3AB"/>
+                </a:solidFill>
+              </a:rPr>
+              <a:t>within its radius?</a:t>
+            </a:r>
+          </a:p>
+        </p:txBody>
+      </p:sp>
+      <p:sp>
+        <p:nvSpPr>
+          <p:cNvPr id="297" name="TextBox 296"/>
+          <p:cNvSpPr txBox="1"/>
+          <p:nvPr/>
+        </p:nvSpPr>
+        <p:spPr>
+          <a:xfrm>
+            <a:off x="548640" y="2606040"/>
+            <a:ext cx="8046720" cy="320040"/>
+          </a:xfrm>
+          <a:prstGeom prst="rect">
+            <a:avLst/>
+          </a:prstGeom>
+          <a:noFill/>
+        </p:spPr>
+        <p:txBody>
+          <a:bodyPr wrap="square">
+            <a:spAutoFit/>
+          </a:bodyPr>
+          <a:lstStyle/>
+          <a:p>
+            <a:pPr algn="ctr"/>
+            <a:r>
+              <a:rPr sz="1400" b="0" i="0">
+                <a:solidFill>
+                  <a:srgbClr val="9AA3AB"/>
+                </a:solidFill>
+              </a:rPr>
+              <a:t>When they overlap, the order of the checks decides:</a:t>
+            </a:r>
+          </a:p>
+        </p:txBody>
+      </p:sp>
+      <p:sp>
+        <p:nvSpPr>
+          <p:cNvPr id="298" name="Rounded Rectangle 297"/>
+          <p:cNvSpPr/>
+          <p:nvPr/>
+        </p:nvSpPr>
+        <p:spPr>
+          <a:xfrm>
+            <a:off x="1463040" y="2971800"/>
+            <a:ext cx="1828800" cy="502920"/>
+          </a:xfrm>
+          <a:prstGeom prst="roundRect">
+            <a:avLst>
+              <a:gd name="adj" fmla="val 12000"/>
+            </a:avLst>
+          </a:prstGeom>
+          <a:solidFill>
+            <a:srgbClr val="2E3338"/>
+          </a:solidFill>
+          <a:ln w="25400">
+            <a:solidFill>
+              <a:srgbClr val="D45D35"/>
+            </a:solidFill>
+          </a:ln>
+          <a:effectLst/>
+        </p:spPr>
+        <p:style>
+          <a:lnRef idx="1">
+            <a:schemeClr val="accent1"/>
+          </a:lnRef>
+          <a:fillRef idx="3">
+            <a:schemeClr val="accent1"/>
+          </a:fillRef>
+          <a:effectRef idx="2">
+            <a:schemeClr val="accent1"/>
+          </a:effectRef>
+          <a:fontRef idx="minor">
+            <a:schemeClr val="lt1"/>
+          </a:fontRef>
+        </p:style>
+        <p:txBody>
+          <a:bodyPr rtlCol="0" anchor="ctr" wrap="square" lIns="73152" rIns="73152"/>
+          <a:lstStyle/>
+          <a:p>
+            <a:pPr algn="ctr"/>
+            <a:r>
+              <a:rPr sz="1500" b="1">
+                <a:solidFill>
+                  <a:srgbClr val="DEE2E6"/>
+                </a:solidFill>
+              </a:rPr>
+              <a:t>Sun</a:t>
+            </a:r>
+          </a:p>
+        </p:txBody>
+      </p:sp>
+      <p:cxnSp>
+        <p:nvCxnSpPr>
+          <p:cNvPr id="299" name="Connector 298"/>
+          <p:cNvCxnSpPr/>
+          <p:nvPr/>
+        </p:nvCxnSpPr>
+        <p:spPr>
+          <a:xfrm>
+            <a:off x="3310128" y="3223260"/>
+            <a:ext cx="237744" cy="0"/>
+          </a:xfrm>
+          <a:prstGeom prst="line">
+            <a:avLst/>
+          </a:prstGeom>
+          <a:ln w="25400">
+            <a:solidFill>
+              <a:srgbClr val="9AA3AB"/>
+            </a:solidFill>
+            <a:tailEnd type="triangle"/>
+          </a:ln>
+        </p:spPr>
+        <p:style>
+          <a:lnRef idx="2">
+            <a:schemeClr val="accent1"/>
+          </a:lnRef>
+          <a:fillRef idx="0">
+            <a:schemeClr val="accent1"/>
+          </a:fillRef>
+          <a:effectRef idx="1">
+            <a:schemeClr val="accent1"/>
+          </a:effectRef>
+          <a:fontRef idx="minor">
+            <a:schemeClr val="tx1"/>
+          </a:fontRef>
+        </p:style>
+      </p:cxnSp>
+      <p:sp>
+        <p:nvSpPr>
+          <p:cNvPr id="300" name="Rounded Rectangle 299"/>
+          <p:cNvSpPr/>
+          <p:nvPr/>
+        </p:nvSpPr>
+        <p:spPr>
+          <a:xfrm>
+            <a:off x="3566160" y="2971800"/>
+            <a:ext cx="1828800" cy="502920"/>
+          </a:xfrm>
+          <a:prstGeom prst="roundRect">
+            <a:avLst>
+              <a:gd name="adj" fmla="val 12000"/>
+            </a:avLst>
+          </a:prstGeom>
+          <a:solidFill>
+            <a:srgbClr val="2E3338"/>
+          </a:solidFill>
+          <a:ln>
+            <a:noFill/>
+          </a:ln>
+          <a:effectLst/>
+        </p:spPr>
+        <p:style>
+          <a:lnRef idx="1">
+            <a:schemeClr val="accent1"/>
+          </a:lnRef>
+          <a:fillRef idx="3">
+            <a:schemeClr val="accent1"/>
+          </a:fillRef>
+          <a:effectRef idx="2">
+            <a:schemeClr val="accent1"/>
+          </a:effectRef>
+          <a:fontRef idx="minor">
+            <a:schemeClr val="lt1"/>
+          </a:fontRef>
+        </p:style>
+        <p:txBody>
+          <a:bodyPr rtlCol="0" anchor="ctr" wrap="square" lIns="73152" rIns="73152"/>
+          <a:lstStyle/>
+          <a:p>
+            <a:pPr algn="ctr"/>
+            <a:r>
+              <a:rPr sz="1500" b="1">
+                <a:solidFill>
+                  <a:srgbClr val="DEE2E6"/>
+                </a:solidFill>
+              </a:rPr>
+              <a:t>Seed packets</a:t>
+            </a:r>
+          </a:p>
+        </p:txBody>
+      </p:sp>
+      <p:cxnSp>
+        <p:nvCxnSpPr>
+          <p:cNvPr id="301" name="Connector 300"/>
+          <p:cNvCxnSpPr/>
+          <p:nvPr/>
+        </p:nvCxnSpPr>
+        <p:spPr>
+          <a:xfrm>
+            <a:off x="5413248" y="3223260"/>
+            <a:ext cx="237744" cy="0"/>
+          </a:xfrm>
+          <a:prstGeom prst="line">
+            <a:avLst/>
+          </a:prstGeom>
+          <a:ln w="25400">
+            <a:solidFill>
+              <a:srgbClr val="9AA3AB"/>
+            </a:solidFill>
+            <a:tailEnd type="triangle"/>
+          </a:ln>
+        </p:spPr>
+        <p:style>
+          <a:lnRef idx="2">
+            <a:schemeClr val="accent1"/>
+          </a:lnRef>
+          <a:fillRef idx="0">
+            <a:schemeClr val="accent1"/>
+          </a:fillRef>
+          <a:effectRef idx="1">
+            <a:schemeClr val="accent1"/>
+          </a:effectRef>
+          <a:fontRef idx="minor">
+            <a:schemeClr val="tx1"/>
+          </a:fontRef>
+        </p:style>
+      </p:cxnSp>
+      <p:sp>
+        <p:nvSpPr>
+          <p:cNvPr id="302" name="Rounded Rectangle 301"/>
+          <p:cNvSpPr/>
+          <p:nvPr/>
+        </p:nvSpPr>
+        <p:spPr>
+          <a:xfrm>
+            <a:off x="5669279" y="2971800"/>
+            <a:ext cx="1828800" cy="502920"/>
+          </a:xfrm>
+          <a:prstGeom prst="roundRect">
+            <a:avLst>
+              <a:gd name="adj" fmla="val 12000"/>
+            </a:avLst>
+          </a:prstGeom>
+          <a:solidFill>
+            <a:srgbClr val="2E3338"/>
+          </a:solidFill>
+          <a:ln>
+            <a:noFill/>
+          </a:ln>
+          <a:effectLst/>
+        </p:spPr>
+        <p:style>
+          <a:lnRef idx="1">
+            <a:schemeClr val="accent1"/>
+          </a:lnRef>
+          <a:fillRef idx="3">
+            <a:schemeClr val="accent1"/>
+          </a:fillRef>
+          <a:effectRef idx="2">
+            <a:schemeClr val="accent1"/>
+          </a:effectRef>
+          <a:fontRef idx="minor">
+            <a:schemeClr val="lt1"/>
+          </a:fontRef>
+        </p:style>
+        <p:txBody>
+          <a:bodyPr rtlCol="0" anchor="ctr" wrap="square" lIns="73152" rIns="73152"/>
+          <a:lstStyle/>
+          <a:p>
+            <a:pPr algn="ctr"/>
+            <a:r>
+              <a:rPr sz="1500" b="1">
+                <a:solidFill>
+                  <a:srgbClr val="DEE2E6"/>
+                </a:solidFill>
+              </a:rPr>
+              <a:t>The lawn</a:t>
+            </a:r>
+          </a:p>
+        </p:txBody>
+      </p:sp>
+      <p:sp>
+        <p:nvSpPr>
+          <p:cNvPr id="303" name="TextBox 302"/>
+          <p:cNvSpPr txBox="1"/>
+          <p:nvPr/>
+        </p:nvSpPr>
+        <p:spPr>
+          <a:xfrm>
+            <a:off x="548640" y="3703320"/>
+            <a:ext cx="8046720" cy="365760"/>
+          </a:xfrm>
+          <a:prstGeom prst="rect">
+            <a:avLst/>
+          </a:prstGeom>
+          <a:noFill/>
+        </p:spPr>
+        <p:txBody>
+          <a:bodyPr wrap="square">
+            <a:spAutoFit/>
+          </a:bodyPr>
+          <a:lstStyle/>
+          <a:p>
+            <a:pPr algn="ctr"/>
+            <a:r>
+              <a:rPr sz="1300" b="0" i="0">
+                <a:solidFill>
+                  <a:srgbClr val="9AA3AB"/>
+                </a:solidFill>
+              </a:rPr>
+              <a:t>And show what a click will do: highlight the cell, with a faint plant.</a:t>
+            </a:r>
           </a:p>
         </p:txBody>
       </p:sp>
@@ -14736,7 +16018,7 @@
         <p:spPr>
           <a:xfrm>
             <a:off x="311700" y="885950"/>
-            <a:ext cx="8520600" cy="4023300"/>
+            <a:ext cx="8520600" cy="521208"/>
           </a:xfrm>
           <a:prstGeom prst="rect">
             <a:avLst/>
@@ -14760,77 +16042,529 @@
             </a:pPr>
             <a:r>
               <a:rPr lang="en"/>
-              <a:t>A class per kind of thing</a:t>
+              <a:t>A class per kind of thing. It works.</a:t>
             </a:r>
             <a:endParaRPr/>
           </a:p>
-          <a:p>
-            <a:pPr indent="-317500" lvl="1" marL="914400" rtl="0" algn="l">
-              <a:spcBef>
-                <a:spcPts val="0"/>
-              </a:spcBef>
-              <a:spcAft>
-                <a:spcPts val="0"/>
-              </a:spcAft>
-              <a:buSzPts val="1400"/>
-              <a:buChar char="○"/>
-            </a:pPr>
-            <a:r>
-              <a:rPr lang="en"/>
-              <a:t>Plant → Sunflower, Peashooter, WallNut</a:t>
-            </a:r>
-            <a:endParaRPr/>
-          </a:p>
-          <a:p>
-            <a:pPr indent="-317500" lvl="1" marL="914400" rtl="0" algn="l">
-              <a:spcBef>
-                <a:spcPts val="0"/>
-              </a:spcBef>
-              <a:spcAft>
-                <a:spcPts val="0"/>
-              </a:spcAft>
-              <a:buSzPts val="1400"/>
-              <a:buChar char="○"/>
-            </a:pPr>
-            <a:r>
-              <a:rPr lang="en"/>
-              <a:t>Zombie, Pea, Sun</a:t>
-            </a:r>
-            <a:endParaRPr/>
-          </a:p>
-          <a:p>
-            <a:pPr indent="-330200" lvl="0" marL="457200" rtl="0" algn="l">
-              <a:spcBef>
-                <a:spcPts val="0"/>
-              </a:spcBef>
-              <a:spcAft>
-                <a:spcPts val="0"/>
-              </a:spcAft>
-              <a:buSzPts val="1600"/>
-              <a:buChar char="●"/>
-            </a:pPr>
-            <a:r>
-              <a:rPr lang="en"/>
-              <a:t>World: one list per class</a:t>
-            </a:r>
-            <a:endParaRPr/>
-          </a:p>
-          <a:p>
-            <a:pPr indent="-330200" lvl="0" marL="457200" rtl="0" algn="l">
-              <a:spcBef>
-                <a:spcPts val="0"/>
-              </a:spcBef>
-              <a:spcAft>
-                <a:spcPts val="0"/>
-              </a:spcAft>
-              <a:buSzPts val="1600"/>
-              <a:buChar char="●"/>
-            </a:pPr>
-            <a:r>
-              <a:rPr lang="en"/>
-              <a:t>It works</a:t>
-            </a:r>
-            <a:endParaRPr/>
+        </p:txBody>
+      </p:sp>
+      <p:sp>
+        <p:nvSpPr>
+          <p:cNvPr id="295" name="Rounded Rectangle 294"/>
+          <p:cNvSpPr/>
+          <p:nvPr/>
+        </p:nvSpPr>
+        <p:spPr>
+          <a:xfrm>
+            <a:off x="1463040" y="1371600"/>
+            <a:ext cx="2011680" cy="502920"/>
+          </a:xfrm>
+          <a:prstGeom prst="roundRect">
+            <a:avLst>
+              <a:gd name="adj" fmla="val 12000"/>
+            </a:avLst>
+          </a:prstGeom>
+          <a:solidFill>
+            <a:srgbClr val="2E3338"/>
+          </a:solidFill>
+          <a:ln>
+            <a:noFill/>
+          </a:ln>
+          <a:effectLst/>
+        </p:spPr>
+        <p:style>
+          <a:lnRef idx="1">
+            <a:schemeClr val="accent1"/>
+          </a:lnRef>
+          <a:fillRef idx="3">
+            <a:schemeClr val="accent1"/>
+          </a:fillRef>
+          <a:effectRef idx="2">
+            <a:schemeClr val="accent1"/>
+          </a:effectRef>
+          <a:fontRef idx="minor">
+            <a:schemeClr val="lt1"/>
+          </a:fontRef>
+        </p:style>
+        <p:txBody>
+          <a:bodyPr rtlCol="0" anchor="ctr" wrap="square" lIns="73152" rIns="73152"/>
+          <a:lstStyle/>
+          <a:p>
+            <a:pPr algn="ctr"/>
+            <a:r>
+              <a:rPr sz="1500" b="1">
+                <a:solidFill>
+                  <a:srgbClr val="DEE2E6"/>
+                </a:solidFill>
+              </a:rPr>
+              <a:t>Plant</a:t>
+            </a:r>
+          </a:p>
+        </p:txBody>
+      </p:sp>
+      <p:sp>
+        <p:nvSpPr>
+          <p:cNvPr id="296" name="Rounded Rectangle 295"/>
+          <p:cNvSpPr/>
+          <p:nvPr/>
+        </p:nvSpPr>
+        <p:spPr>
+          <a:xfrm>
+            <a:off x="365760" y="2286000"/>
+            <a:ext cx="1325880" cy="502920"/>
+          </a:xfrm>
+          <a:prstGeom prst="roundRect">
+            <a:avLst>
+              <a:gd name="adj" fmla="val 12000"/>
+            </a:avLst>
+          </a:prstGeom>
+          <a:solidFill>
+            <a:srgbClr val="2E3338"/>
+          </a:solidFill>
+          <a:ln>
+            <a:noFill/>
+          </a:ln>
+          <a:effectLst/>
+        </p:spPr>
+        <p:style>
+          <a:lnRef idx="1">
+            <a:schemeClr val="accent1"/>
+          </a:lnRef>
+          <a:fillRef idx="3">
+            <a:schemeClr val="accent1"/>
+          </a:fillRef>
+          <a:effectRef idx="2">
+            <a:schemeClr val="accent1"/>
+          </a:effectRef>
+          <a:fontRef idx="minor">
+            <a:schemeClr val="lt1"/>
+          </a:fontRef>
+        </p:style>
+        <p:txBody>
+          <a:bodyPr rtlCol="0" anchor="ctr" wrap="square" lIns="73152" rIns="73152"/>
+          <a:lstStyle/>
+          <a:p>
+            <a:pPr algn="ctr"/>
+            <a:r>
+              <a:rPr sz="1300" b="1">
+                <a:solidFill>
+                  <a:srgbClr val="DEE2E6"/>
+                </a:solidFill>
+              </a:rPr>
+              <a:t>Sunflower</a:t>
+            </a:r>
+          </a:p>
+        </p:txBody>
+      </p:sp>
+      <p:cxnSp>
+        <p:nvCxnSpPr>
+          <p:cNvPr id="297" name="Connector 296"/>
+          <p:cNvCxnSpPr/>
+          <p:nvPr/>
+        </p:nvCxnSpPr>
+        <p:spPr>
+          <a:xfrm flipV="1">
+            <a:off x="1024128" y="1892807"/>
+            <a:ext cx="1444752" cy="374905"/>
+          </a:xfrm>
+          <a:prstGeom prst="line">
+            <a:avLst/>
+          </a:prstGeom>
+          <a:ln w="25400">
+            <a:solidFill>
+              <a:srgbClr val="9AA3AB"/>
+            </a:solidFill>
+            <a:tailEnd type="triangle"/>
+          </a:ln>
+        </p:spPr>
+        <p:style>
+          <a:lnRef idx="2">
+            <a:schemeClr val="accent1"/>
+          </a:lnRef>
+          <a:fillRef idx="0">
+            <a:schemeClr val="accent1"/>
+          </a:fillRef>
+          <a:effectRef idx="1">
+            <a:schemeClr val="accent1"/>
+          </a:effectRef>
+          <a:fontRef idx="minor">
+            <a:schemeClr val="tx1"/>
+          </a:fontRef>
+        </p:style>
+      </p:cxnSp>
+      <p:sp>
+        <p:nvSpPr>
+          <p:cNvPr id="298" name="Rounded Rectangle 297"/>
+          <p:cNvSpPr/>
+          <p:nvPr/>
+        </p:nvSpPr>
+        <p:spPr>
+          <a:xfrm>
+            <a:off x="1828800" y="2286000"/>
+            <a:ext cx="1325880" cy="502920"/>
+          </a:xfrm>
+          <a:prstGeom prst="roundRect">
+            <a:avLst>
+              <a:gd name="adj" fmla="val 12000"/>
+            </a:avLst>
+          </a:prstGeom>
+          <a:solidFill>
+            <a:srgbClr val="2E3338"/>
+          </a:solidFill>
+          <a:ln>
+            <a:noFill/>
+          </a:ln>
+          <a:effectLst/>
+        </p:spPr>
+        <p:style>
+          <a:lnRef idx="1">
+            <a:schemeClr val="accent1"/>
+          </a:lnRef>
+          <a:fillRef idx="3">
+            <a:schemeClr val="accent1"/>
+          </a:fillRef>
+          <a:effectRef idx="2">
+            <a:schemeClr val="accent1"/>
+          </a:effectRef>
+          <a:fontRef idx="minor">
+            <a:schemeClr val="lt1"/>
+          </a:fontRef>
+        </p:style>
+        <p:txBody>
+          <a:bodyPr rtlCol="0" anchor="ctr" wrap="square" lIns="73152" rIns="73152"/>
+          <a:lstStyle/>
+          <a:p>
+            <a:pPr algn="ctr"/>
+            <a:r>
+              <a:rPr sz="1300" b="1">
+                <a:solidFill>
+                  <a:srgbClr val="DEE2E6"/>
+                </a:solidFill>
+              </a:rPr>
+              <a:t>Peashooter</a:t>
+            </a:r>
+          </a:p>
+        </p:txBody>
+      </p:sp>
+      <p:cxnSp>
+        <p:nvCxnSpPr>
+          <p:cNvPr id="299" name="Connector 298"/>
+          <p:cNvCxnSpPr/>
+          <p:nvPr/>
+        </p:nvCxnSpPr>
+        <p:spPr>
+          <a:xfrm flipH="1" flipV="1">
+            <a:off x="2468880" y="1892807"/>
+            <a:ext cx="18288" cy="374905"/>
+          </a:xfrm>
+          <a:prstGeom prst="line">
+            <a:avLst/>
+          </a:prstGeom>
+          <a:ln w="25400">
+            <a:solidFill>
+              <a:srgbClr val="9AA3AB"/>
+            </a:solidFill>
+            <a:tailEnd type="triangle"/>
+          </a:ln>
+        </p:spPr>
+        <p:style>
+          <a:lnRef idx="2">
+            <a:schemeClr val="accent1"/>
+          </a:lnRef>
+          <a:fillRef idx="0">
+            <a:schemeClr val="accent1"/>
+          </a:fillRef>
+          <a:effectRef idx="1">
+            <a:schemeClr val="accent1"/>
+          </a:effectRef>
+          <a:fontRef idx="minor">
+            <a:schemeClr val="tx1"/>
+          </a:fontRef>
+        </p:style>
+      </p:cxnSp>
+      <p:sp>
+        <p:nvSpPr>
+          <p:cNvPr id="300" name="Rounded Rectangle 299"/>
+          <p:cNvSpPr/>
+          <p:nvPr/>
+        </p:nvSpPr>
+        <p:spPr>
+          <a:xfrm>
+            <a:off x="3291840" y="2286000"/>
+            <a:ext cx="1325880" cy="502920"/>
+          </a:xfrm>
+          <a:prstGeom prst="roundRect">
+            <a:avLst>
+              <a:gd name="adj" fmla="val 12000"/>
+            </a:avLst>
+          </a:prstGeom>
+          <a:solidFill>
+            <a:srgbClr val="2E3338"/>
+          </a:solidFill>
+          <a:ln>
+            <a:noFill/>
+          </a:ln>
+          <a:effectLst/>
+        </p:spPr>
+        <p:style>
+          <a:lnRef idx="1">
+            <a:schemeClr val="accent1"/>
+          </a:lnRef>
+          <a:fillRef idx="3">
+            <a:schemeClr val="accent1"/>
+          </a:fillRef>
+          <a:effectRef idx="2">
+            <a:schemeClr val="accent1"/>
+          </a:effectRef>
+          <a:fontRef idx="minor">
+            <a:schemeClr val="lt1"/>
+          </a:fontRef>
+        </p:style>
+        <p:txBody>
+          <a:bodyPr rtlCol="0" anchor="ctr" wrap="square" lIns="73152" rIns="73152"/>
+          <a:lstStyle/>
+          <a:p>
+            <a:pPr algn="ctr"/>
+            <a:r>
+              <a:rPr sz="1300" b="1">
+                <a:solidFill>
+                  <a:srgbClr val="DEE2E6"/>
+                </a:solidFill>
+              </a:rPr>
+              <a:t>WallNut</a:t>
+            </a:r>
+          </a:p>
+        </p:txBody>
+      </p:sp>
+      <p:cxnSp>
+        <p:nvCxnSpPr>
+          <p:cNvPr id="301" name="Connector 300"/>
+          <p:cNvCxnSpPr/>
+          <p:nvPr/>
+        </p:nvCxnSpPr>
+        <p:spPr>
+          <a:xfrm flipH="1" flipV="1">
+            <a:off x="2468880" y="1892807"/>
+            <a:ext cx="1481328" cy="374905"/>
+          </a:xfrm>
+          <a:prstGeom prst="line">
+            <a:avLst/>
+          </a:prstGeom>
+          <a:ln w="25400">
+            <a:solidFill>
+              <a:srgbClr val="9AA3AB"/>
+            </a:solidFill>
+            <a:tailEnd type="triangle"/>
+          </a:ln>
+        </p:spPr>
+        <p:style>
+          <a:lnRef idx="2">
+            <a:schemeClr val="accent1"/>
+          </a:lnRef>
+          <a:fillRef idx="0">
+            <a:schemeClr val="accent1"/>
+          </a:fillRef>
+          <a:effectRef idx="1">
+            <a:schemeClr val="accent1"/>
+          </a:effectRef>
+          <a:fontRef idx="minor">
+            <a:schemeClr val="tx1"/>
+          </a:fontRef>
+        </p:style>
+      </p:cxnSp>
+      <p:sp>
+        <p:nvSpPr>
+          <p:cNvPr id="302" name="Rounded Rectangle 301"/>
+          <p:cNvSpPr/>
+          <p:nvPr/>
+        </p:nvSpPr>
+        <p:spPr>
+          <a:xfrm>
+            <a:off x="4846320" y="1371600"/>
+            <a:ext cx="1371600" cy="502920"/>
+          </a:xfrm>
+          <a:prstGeom prst="roundRect">
+            <a:avLst>
+              <a:gd name="adj" fmla="val 12000"/>
+            </a:avLst>
+          </a:prstGeom>
+          <a:solidFill>
+            <a:srgbClr val="2E3338"/>
+          </a:solidFill>
+          <a:ln>
+            <a:noFill/>
+          </a:ln>
+          <a:effectLst/>
+        </p:spPr>
+        <p:style>
+          <a:lnRef idx="1">
+            <a:schemeClr val="accent1"/>
+          </a:lnRef>
+          <a:fillRef idx="3">
+            <a:schemeClr val="accent1"/>
+          </a:fillRef>
+          <a:effectRef idx="2">
+            <a:schemeClr val="accent1"/>
+          </a:effectRef>
+          <a:fontRef idx="minor">
+            <a:schemeClr val="lt1"/>
+          </a:fontRef>
+        </p:style>
+        <p:txBody>
+          <a:bodyPr rtlCol="0" anchor="ctr" wrap="square" lIns="73152" rIns="73152"/>
+          <a:lstStyle/>
+          <a:p>
+            <a:pPr algn="ctr"/>
+            <a:r>
+              <a:rPr sz="1500" b="1">
+                <a:solidFill>
+                  <a:srgbClr val="DEE2E6"/>
+                </a:solidFill>
+              </a:rPr>
+              <a:t>Zombie</a:t>
+            </a:r>
+          </a:p>
+        </p:txBody>
+      </p:sp>
+      <p:sp>
+        <p:nvSpPr>
+          <p:cNvPr id="303" name="Rounded Rectangle 302"/>
+          <p:cNvSpPr/>
+          <p:nvPr/>
+        </p:nvSpPr>
+        <p:spPr>
+          <a:xfrm>
+            <a:off x="6355080" y="1371600"/>
+            <a:ext cx="1097280" cy="502920"/>
+          </a:xfrm>
+          <a:prstGeom prst="roundRect">
+            <a:avLst>
+              <a:gd name="adj" fmla="val 12000"/>
+            </a:avLst>
+          </a:prstGeom>
+          <a:solidFill>
+            <a:srgbClr val="2E3338"/>
+          </a:solidFill>
+          <a:ln>
+            <a:noFill/>
+          </a:ln>
+          <a:effectLst/>
+        </p:spPr>
+        <p:style>
+          <a:lnRef idx="1">
+            <a:schemeClr val="accent1"/>
+          </a:lnRef>
+          <a:fillRef idx="3">
+            <a:schemeClr val="accent1"/>
+          </a:fillRef>
+          <a:effectRef idx="2">
+            <a:schemeClr val="accent1"/>
+          </a:effectRef>
+          <a:fontRef idx="minor">
+            <a:schemeClr val="lt1"/>
+          </a:fontRef>
+        </p:style>
+        <p:txBody>
+          <a:bodyPr rtlCol="0" anchor="ctr" wrap="square" lIns="73152" rIns="73152"/>
+          <a:lstStyle/>
+          <a:p>
+            <a:pPr algn="ctr"/>
+            <a:r>
+              <a:rPr sz="1500" b="1">
+                <a:solidFill>
+                  <a:srgbClr val="DEE2E6"/>
+                </a:solidFill>
+              </a:rPr>
+              <a:t>Pea</a:t>
+            </a:r>
+          </a:p>
+        </p:txBody>
+      </p:sp>
+      <p:sp>
+        <p:nvSpPr>
+          <p:cNvPr id="304" name="Rounded Rectangle 303"/>
+          <p:cNvSpPr/>
+          <p:nvPr/>
+        </p:nvSpPr>
+        <p:spPr>
+          <a:xfrm>
+            <a:off x="7589520" y="1371600"/>
+            <a:ext cx="1097280" cy="502920"/>
+          </a:xfrm>
+          <a:prstGeom prst="roundRect">
+            <a:avLst>
+              <a:gd name="adj" fmla="val 12000"/>
+            </a:avLst>
+          </a:prstGeom>
+          <a:solidFill>
+            <a:srgbClr val="2E3338"/>
+          </a:solidFill>
+          <a:ln>
+            <a:noFill/>
+          </a:ln>
+          <a:effectLst/>
+        </p:spPr>
+        <p:style>
+          <a:lnRef idx="1">
+            <a:schemeClr val="accent1"/>
+          </a:lnRef>
+          <a:fillRef idx="3">
+            <a:schemeClr val="accent1"/>
+          </a:fillRef>
+          <a:effectRef idx="2">
+            <a:schemeClr val="accent1"/>
+          </a:effectRef>
+          <a:fontRef idx="minor">
+            <a:schemeClr val="lt1"/>
+          </a:fontRef>
+        </p:style>
+        <p:txBody>
+          <a:bodyPr rtlCol="0" anchor="ctr" wrap="square" lIns="73152" rIns="73152"/>
+          <a:lstStyle/>
+          <a:p>
+            <a:pPr algn="ctr"/>
+            <a:r>
+              <a:rPr sz="1500" b="1">
+                <a:solidFill>
+                  <a:srgbClr val="DEE2E6"/>
+                </a:solidFill>
+              </a:rPr>
+              <a:t>Sun</a:t>
+            </a:r>
+          </a:p>
+        </p:txBody>
+      </p:sp>
+      <p:sp>
+        <p:nvSpPr>
+          <p:cNvPr id="305" name="TextBox 304"/>
+          <p:cNvSpPr txBox="1"/>
+          <p:nvPr/>
+        </p:nvSpPr>
+        <p:spPr>
+          <a:xfrm>
+            <a:off x="365760" y="3108960"/>
+            <a:ext cx="8412480" cy="365760"/>
+          </a:xfrm>
+          <a:prstGeom prst="rect">
+            <a:avLst/>
+          </a:prstGeom>
+          <a:noFill/>
+        </p:spPr>
+        <p:txBody>
+          <a:bodyPr wrap="square">
+            <a:spAutoFit/>
+          </a:bodyPr>
+          <a:lstStyle/>
+          <a:p>
+            <a:pPr algn="ctr"/>
+            <a:r>
+              <a:rPr sz="1400" b="0" i="0">
+                <a:solidFill>
+                  <a:srgbClr val="9AA3AB"/>
+                </a:solidFill>
+              </a:rPr>
+              <a:t>The World keeps one list per class.</a:t>
+            </a:r>
           </a:p>
         </p:txBody>
       </p:sp>
@@ -14911,7 +16645,7 @@
         <p:spPr>
           <a:xfrm>
             <a:off x="311700" y="885950"/>
-            <a:ext cx="8520600" cy="4023300"/>
+            <a:ext cx="8520600" cy="521208"/>
           </a:xfrm>
           <a:prstGeom prst="rect">
             <a:avLst/>
@@ -14935,94 +16669,349 @@
             </a:pPr>
             <a:r>
               <a:rPr lang="en"/>
-              <a:t>A Repeater: a Peashooter subclass that overrides… what?</a:t>
+              <a:t>Four new things. Where does each one go?</a:t>
             </a:r>
             <a:endParaRPr/>
           </a:p>
-          <a:p>
-            <a:pPr indent="-330200" lvl="0" marL="457200" rtl="0" algn="l">
-              <a:spcBef>
-                <a:spcPts val="0"/>
-              </a:spcBef>
-              <a:spcAft>
-                <a:spcPts val="0"/>
-              </a:spcAft>
-              <a:buSzPts val="1600"/>
-              <a:buChar char="●"/>
-            </a:pPr>
-            <a:r>
-              <a:rPr lang="en"/>
-              <a:t>A Conehead: a Zombie subclass. A plant with armour: copy it</a:t>
-            </a:r>
-            <a:endParaRPr/>
-          </a:p>
-          <a:p>
-            <a:pPr indent="-330200" lvl="0" marL="457200" rtl="0" algn="l">
-              <a:spcBef>
-                <a:spcPts val="0"/>
-              </a:spcBef>
-              <a:spcAft>
-                <a:spcPts val="0"/>
-              </a:spcAft>
-              <a:buSzPts val="1600"/>
-              <a:buChar char="●"/>
-            </a:pPr>
-            <a:r>
-              <a:rPr lang="en"/>
-              <a:t>A plant that shoots and makes sun: which parent?</a:t>
-            </a:r>
-            <a:endParaRPr/>
-          </a:p>
-          <a:p>
-            <a:pPr indent="-317500" lvl="1" marL="914400" rtl="0" algn="l">
-              <a:spcBef>
-                <a:spcPts val="0"/>
-              </a:spcBef>
-              <a:spcAft>
-                <a:spcPts val="0"/>
-              </a:spcAft>
-              <a:buSzPts val="1400"/>
-              <a:buChar char="○"/>
-            </a:pPr>
-            <a:r>
-              <a:rPr lang="en"/>
-              <a:t>C# allows one base class: copy the other ability</a:t>
-            </a:r>
-            <a:endParaRPr/>
-          </a:p>
-          <a:p>
-            <a:pPr indent="-330200" lvl="0" marL="457200" rtl="0" algn="l">
-              <a:spcBef>
-                <a:spcPts val="0"/>
-              </a:spcBef>
-              <a:spcAft>
-                <a:spcPts val="0"/>
-              </a:spcAft>
-              <a:buSzPts val="1600"/>
-              <a:buChar char="●"/>
-            </a:pPr>
-            <a:r>
-              <a:rPr lang="en"/>
-              <a:t>Health is already copied: a zombie isn’t a plant</a:t>
-            </a:r>
-            <a:endParaRPr/>
-          </a:p>
-          <a:p>
-            <a:pPr indent="-330200" lvl="0" marL="457200" rtl="0" algn="l">
-              <a:spcBef>
-                <a:spcPts val="0"/>
-              </a:spcBef>
-              <a:spcAft>
-                <a:spcPts val="0"/>
-              </a:spcAft>
-              <a:buSzPts val="1600"/>
-              <a:buChar char="●"/>
-            </a:pPr>
-            <a:r>
-              <a:rPr lang="en"/>
-              <a:t>Inheritance says what something is; here, what matters is what it can do</a:t>
-            </a:r>
-            <a:endParaRPr/>
+        </p:txBody>
+      </p:sp>
+      <p:sp>
+        <p:nvSpPr>
+          <p:cNvPr id="295" name="Rounded Rectangle 294"/>
+          <p:cNvSpPr/>
+          <p:nvPr/>
+        </p:nvSpPr>
+        <p:spPr>
+          <a:xfrm>
+            <a:off x="411480" y="1417320"/>
+            <a:ext cx="1965960" cy="1188720"/>
+          </a:xfrm>
+          <a:prstGeom prst="roundRect">
+            <a:avLst>
+              <a:gd name="adj" fmla="val 12000"/>
+            </a:avLst>
+          </a:prstGeom>
+          <a:solidFill>
+            <a:srgbClr val="2E3338"/>
+          </a:solidFill>
+          <a:ln>
+            <a:noFill/>
+          </a:ln>
+          <a:effectLst/>
+        </p:spPr>
+        <p:style>
+          <a:lnRef idx="1">
+            <a:schemeClr val="accent1"/>
+          </a:lnRef>
+          <a:fillRef idx="3">
+            <a:schemeClr val="accent1"/>
+          </a:fillRef>
+          <a:effectRef idx="2">
+            <a:schemeClr val="accent1"/>
+          </a:effectRef>
+          <a:fontRef idx="minor">
+            <a:schemeClr val="lt1"/>
+          </a:fontRef>
+        </p:style>
+        <p:txBody>
+          <a:bodyPr rtlCol="0" anchor="ctr" wrap="square" lIns="73152" rIns="73152"/>
+          <a:lstStyle/>
+          <a:p>
+            <a:pPr algn="ctr"/>
+            <a:r>
+              <a:rPr sz="1500" b="1">
+                <a:solidFill>
+                  <a:srgbClr val="DEE2E6"/>
+                </a:solidFill>
+              </a:rPr>
+              <a:t>Repeater</a:t>
+            </a:r>
+          </a:p>
+          <a:p>
+            <a:pPr algn="ctr"/>
+            <a:r>
+              <a:rPr sz="1300" b="0">
+                <a:solidFill>
+                  <a:srgbClr val="9AA3AB"/>
+                </a:solidFill>
+              </a:rPr>
+              <a:t>a Peashooter subclass</a:t>
+            </a:r>
+          </a:p>
+          <a:p>
+            <a:pPr algn="ctr"/>
+            <a:r>
+              <a:rPr sz="1300" b="0">
+                <a:solidFill>
+                  <a:srgbClr val="9AA3AB"/>
+                </a:solidFill>
+              </a:rPr>
+              <a:t>that overrides... what?</a:t>
+            </a:r>
+          </a:p>
+        </p:txBody>
+      </p:sp>
+      <p:sp>
+        <p:nvSpPr>
+          <p:cNvPr id="296" name="Rounded Rectangle 295"/>
+          <p:cNvSpPr/>
+          <p:nvPr/>
+        </p:nvSpPr>
+        <p:spPr>
+          <a:xfrm>
+            <a:off x="2514600" y="1417320"/>
+            <a:ext cx="1965960" cy="1188720"/>
+          </a:xfrm>
+          <a:prstGeom prst="roundRect">
+            <a:avLst>
+              <a:gd name="adj" fmla="val 12000"/>
+            </a:avLst>
+          </a:prstGeom>
+          <a:solidFill>
+            <a:srgbClr val="2E3338"/>
+          </a:solidFill>
+          <a:ln>
+            <a:noFill/>
+          </a:ln>
+          <a:effectLst/>
+        </p:spPr>
+        <p:style>
+          <a:lnRef idx="1">
+            <a:schemeClr val="accent1"/>
+          </a:lnRef>
+          <a:fillRef idx="3">
+            <a:schemeClr val="accent1"/>
+          </a:fillRef>
+          <a:effectRef idx="2">
+            <a:schemeClr val="accent1"/>
+          </a:effectRef>
+          <a:fontRef idx="minor">
+            <a:schemeClr val="lt1"/>
+          </a:fontRef>
+        </p:style>
+        <p:txBody>
+          <a:bodyPr rtlCol="0" anchor="ctr" wrap="square" lIns="73152" rIns="73152"/>
+          <a:lstStyle/>
+          <a:p>
+            <a:pPr algn="ctr"/>
+            <a:r>
+              <a:rPr sz="1500" b="1">
+                <a:solidFill>
+                  <a:srgbClr val="DEE2E6"/>
+                </a:solidFill>
+              </a:rPr>
+              <a:t>Conehead</a:t>
+            </a:r>
+          </a:p>
+          <a:p>
+            <a:pPr algn="ctr"/>
+            <a:r>
+              <a:rPr sz="1300" b="0">
+                <a:solidFill>
+                  <a:srgbClr val="9AA3AB"/>
+                </a:solidFill>
+              </a:rPr>
+              <a:t>a Zombie subclass;</a:t>
+            </a:r>
+          </a:p>
+          <a:p>
+            <a:pPr algn="ctr"/>
+            <a:r>
+              <a:rPr sz="1300" b="0">
+                <a:solidFill>
+                  <a:srgbClr val="9AA3AB"/>
+                </a:solidFill>
+              </a:rPr>
+              <a:t>armour for a plant: copy it</a:t>
+            </a:r>
+          </a:p>
+        </p:txBody>
+      </p:sp>
+      <p:sp>
+        <p:nvSpPr>
+          <p:cNvPr id="297" name="Rounded Rectangle 296"/>
+          <p:cNvSpPr/>
+          <p:nvPr/>
+        </p:nvSpPr>
+        <p:spPr>
+          <a:xfrm>
+            <a:off x="4617720" y="1417320"/>
+            <a:ext cx="1965960" cy="1188720"/>
+          </a:xfrm>
+          <a:prstGeom prst="roundRect">
+            <a:avLst>
+              <a:gd name="adj" fmla="val 12000"/>
+            </a:avLst>
+          </a:prstGeom>
+          <a:solidFill>
+            <a:srgbClr val="2E3338"/>
+          </a:solidFill>
+          <a:ln w="25400">
+            <a:solidFill>
+              <a:srgbClr val="D45D35"/>
+            </a:solidFill>
+          </a:ln>
+          <a:effectLst/>
+        </p:spPr>
+        <p:style>
+          <a:lnRef idx="1">
+            <a:schemeClr val="accent1"/>
+          </a:lnRef>
+          <a:fillRef idx="3">
+            <a:schemeClr val="accent1"/>
+          </a:fillRef>
+          <a:effectRef idx="2">
+            <a:schemeClr val="accent1"/>
+          </a:effectRef>
+          <a:fontRef idx="minor">
+            <a:schemeClr val="lt1"/>
+          </a:fontRef>
+        </p:style>
+        <p:txBody>
+          <a:bodyPr rtlCol="0" anchor="ctr" wrap="square" lIns="73152" rIns="73152"/>
+          <a:lstStyle/>
+          <a:p>
+            <a:pPr algn="ctr"/>
+            <a:r>
+              <a:rPr sz="1500" b="1">
+                <a:solidFill>
+                  <a:srgbClr val="DEE2E6"/>
+                </a:solidFill>
+              </a:rPr>
+              <a:t>Shoots and makes sun</a:t>
+            </a:r>
+          </a:p>
+          <a:p>
+            <a:pPr algn="ctr"/>
+            <a:r>
+              <a:rPr sz="1300" b="0">
+                <a:solidFill>
+                  <a:srgbClr val="9AA3AB"/>
+                </a:solidFill>
+              </a:rPr>
+              <a:t>which parent?</a:t>
+            </a:r>
+          </a:p>
+          <a:p>
+            <a:pPr algn="ctr"/>
+            <a:r>
+              <a:rPr sz="1300" b="0">
+                <a:solidFill>
+                  <a:srgbClr val="9AA3AB"/>
+                </a:solidFill>
+              </a:rPr>
+              <a:t>C# allows only one</a:t>
+            </a:r>
+          </a:p>
+        </p:txBody>
+      </p:sp>
+      <p:sp>
+        <p:nvSpPr>
+          <p:cNvPr id="298" name="Rounded Rectangle 297"/>
+          <p:cNvSpPr/>
+          <p:nvPr/>
+        </p:nvSpPr>
+        <p:spPr>
+          <a:xfrm>
+            <a:off x="6720840" y="1417320"/>
+            <a:ext cx="1965960" cy="1188720"/>
+          </a:xfrm>
+          <a:prstGeom prst="roundRect">
+            <a:avLst>
+              <a:gd name="adj" fmla="val 12000"/>
+            </a:avLst>
+          </a:prstGeom>
+          <a:solidFill>
+            <a:srgbClr val="2E3338"/>
+          </a:solidFill>
+          <a:ln>
+            <a:noFill/>
+          </a:ln>
+          <a:effectLst/>
+        </p:spPr>
+        <p:style>
+          <a:lnRef idx="1">
+            <a:schemeClr val="accent1"/>
+          </a:lnRef>
+          <a:fillRef idx="3">
+            <a:schemeClr val="accent1"/>
+          </a:fillRef>
+          <a:effectRef idx="2">
+            <a:schemeClr val="accent1"/>
+          </a:effectRef>
+          <a:fontRef idx="minor">
+            <a:schemeClr val="lt1"/>
+          </a:fontRef>
+        </p:style>
+        <p:txBody>
+          <a:bodyPr rtlCol="0" anchor="ctr" wrap="square" lIns="73152" rIns="73152"/>
+          <a:lstStyle/>
+          <a:p>
+            <a:pPr algn="ctr"/>
+            <a:r>
+              <a:rPr sz="1500" b="1">
+                <a:solidFill>
+                  <a:srgbClr val="DEE2E6"/>
+                </a:solidFill>
+              </a:rPr>
+              <a:t>Health</a:t>
+            </a:r>
+          </a:p>
+          <a:p>
+            <a:pPr algn="ctr"/>
+            <a:r>
+              <a:rPr sz="1300" b="0">
+                <a:solidFill>
+                  <a:srgbClr val="9AA3AB"/>
+                </a:solidFill>
+              </a:rPr>
+              <a:t>already copied:</a:t>
+            </a:r>
+          </a:p>
+          <a:p>
+            <a:pPr algn="ctr"/>
+            <a:r>
+              <a:rPr sz="1300" b="0">
+                <a:solidFill>
+                  <a:srgbClr val="9AA3AB"/>
+                </a:solidFill>
+              </a:rPr>
+              <a:t>a zombie isn’t a plant</a:t>
+            </a:r>
+          </a:p>
+        </p:txBody>
+      </p:sp>
+      <p:sp>
+        <p:nvSpPr>
+          <p:cNvPr id="299" name="TextBox 298"/>
+          <p:cNvSpPr txBox="1"/>
+          <p:nvPr/>
+        </p:nvSpPr>
+        <p:spPr>
+          <a:xfrm>
+            <a:off x="457200" y="2926080"/>
+            <a:ext cx="8229600" cy="731520"/>
+          </a:xfrm>
+          <a:prstGeom prst="rect">
+            <a:avLst/>
+          </a:prstGeom>
+          <a:noFill/>
+        </p:spPr>
+        <p:txBody>
+          <a:bodyPr wrap="square">
+            <a:spAutoFit/>
+          </a:bodyPr>
+          <a:lstStyle/>
+          <a:p>
+            <a:pPr algn="ctr"/>
+            <a:r>
+              <a:rPr sz="1600" b="1" i="0">
+                <a:solidFill>
+                  <a:srgbClr val="DEE2E6"/>
+                </a:solidFill>
+              </a:rPr>
+              <a:t>Inheritance says what something is. Here, what matters is what it can do.</a:t>
+            </a:r>
           </a:p>
         </p:txBody>
       </p:sp>

</xml_diff>

<commit_message>
Plants vs. Zombies: the page, deck and recording follow the castle and its goblins
Co-Authored-By: Claude Opus 5.5 <noreply@anthropic.com>
Claude-Session: https://claude.ai/code/session_012sjsUQBbC7zon57rWHoo9d
</commit_message>
<xml_diff>
--- a/slides/09 Plants vs. Zombies.pptx
+++ b/slides/09 Plants vs. Zombies.pptx
@@ -881,7 +881,7 @@
           </a:p>
           <a:p>
             <a:r>
-              <a:t>Ask the third question: a pea hits a zombie; whose rule is it? Geometry Wars answers with systems.</a:t>
+              <a:t>Ask the third question: an arrow hits a goblin; whose rule is it? Geometry Wars answers with systems.</a:t>
             </a:r>
           </a:p>
         </p:txBody>
@@ -944,7 +944,7 @@
           </a:p>
           <a:p>
             <a:r>
-              <a:t>Ask the question: a plant’s cost, in each plant or in its type? The type.</a:t>
+              <a:t>Ask the question: a defender’s cost, in each defender or in its type? The type.</a:t>
             </a:r>
           </a:p>
         </p:txBody>
@@ -1013,12 +1013,12 @@
           <a:p/>
           <a:p>
             <a:r>
-              <a:t>Q: Why does inheritance break down for Plants vs. Zombies?</a:t>
-            </a:r>
-          </a:p>
-          <a:p>
-            <a:r>
-              <a:t>A: The abilities (shooting, making sun, armour, walking, eating) combine freely, but a class has one base class. Combinations mean choosing one parent and copying the other ability, and abilities shared by plants and zombies (health) get copied too.</a:t>
+              <a:t>Q: Why does inheritance break down for this game?</a:t>
+            </a:r>
+          </a:p>
+          <a:p>
+            <a:r>
+              <a:t>A: The abilities (shooting, making gold, armour, walking, attacking) combine freely, but a class has one base class. Combinations mean choosing one parent and copying the other ability, and abilities shared by defenders and goblins (health) get copied too.</a:t>
             </a:r>
           </a:p>
           <a:p/>
@@ -1029,7 +1029,7 @@
           </a:p>
           <a:p>
             <a:r>
-              <a:t>A: They ask their owner for a sibling (Owner.Get&lt;Eater&gt;()), and handle it being missing. For other entities, they ask the world.</a:t>
+              <a:t>A: They ask their owner for a sibling (Owner.Get&lt;Attacker&gt;()), and handle it being missing. For other entities, they ask the world.</a:t>
             </a:r>
           </a:p>
           <a:p/>
@@ -1172,12 +1172,12 @@
           </a:p>
           <a:p>
             <a:r>
-              <a:t>- choose a packet, hover the lawn: the highlighted cell and the faint plant</a:t>
-            </a:r>
-          </a:p>
-          <a:p>
-            <a:r>
-              <a:t>- click to plant</a:t>
+              <a:t>- choose a card, hover the field: the highlighted cell and the faint defender</a:t>
+            </a:r>
+          </a:p>
+          <a:p>
+            <a:r>
+              <a:t>- click to place a defender</a:t>
             </a:r>
           </a:p>
         </p:txBody>
@@ -1240,7 +1240,7 @@
           </a:p>
           <a:p>
             <a:r>
-              <a:t>- the Plant and Zombie hierarchies</a:t>
+              <a:t>- the Defender and Goblin hierarchies</a:t>
             </a:r>
           </a:p>
           <a:p>
@@ -1361,7 +1361,7 @@
           <a:lstStyle/>
           <a:p>
             <a:r>
-              <a:t>No classes for plants or zombies: each kind is a list of components. A Repeater and a Conehead are recipes. Health is written once.</a:t>
+              <a:t>No classes for defenders or goblins: each kind is a list of components. A Wizard and a Shieldbearer are recipes. Health is written once.</a:t>
             </a:r>
           </a:p>
         </p:txBody>
@@ -1419,7 +1419,7 @@
           <a:lstStyle/>
           <a:p>
             <a:r>
-              <a:t>Through the owner (the walker checks the eater) or through the world (a shooter asks for a zombie ahead in its row).</a:t>
+              <a:t>Through the owner (the walker checks the attacker) or through the world (a shooter asks for a goblin ahead in its row).</a:t>
             </a:r>
           </a:p>
           <a:p>
@@ -1649,7 +1649,7 @@
           <a:lstStyle/>
           <a:p>
             <a:r>
-              <a:t>A peashooter’s cost isn’t in any one peashooter: it belongs to the kind. One PlantType per kind, loaded from plants.json.</a:t>
+              <a:t>An archer’s cost isn’t in any one archer: it belongs to the kind. One DefenderType per kind, loaded from defenders.json.</a:t>
             </a:r>
           </a:p>
         </p:txBody>
@@ -1770,7 +1770,7 @@
           </a:p>
           <a:p>
             <a:r>
-              <a:t>- plants.json and zombies.json</a:t>
+              <a:t>- defenders.json and goblins.json</a:t>
             </a:r>
           </a:p>
           <a:p>
@@ -1838,7 +1838,7 @@
           <a:lstStyle/>
           <a:p>
             <a:r>
-              <a:t>A level from JSON, packets that recharge, sun from the sky (a sun with one more component, Faller), winning and losing.</a:t>
+              <a:t>A level from JSON, cards that recharge, gold from the sky (a coin with one more component, Faller), winning and losing.</a:t>
             </a:r>
           </a:p>
         </p:txBody>
@@ -1985,7 +1985,7 @@
           <a:lstStyle/>
           <a:p>
             <a:r>
-              <a:t>Demo: play a minute of Pvz4: collect sun, plant a sunflower and a peashooter, watch a conehead lose its cone.</a:t>
+              <a:t>Demo: play a minute of Pvz4: collect gold, place a chest and an archer, watch a shieldbearer lose its shield.</a:t>
             </a:r>
           </a:p>
         </p:txBody>
@@ -2227,7 +2227,7 @@
           <a:lstStyle/>
           <a:p>
             <a:r>
-              <a:t>Pairs, about 7 minutes. One recipe: Plant(...).With(new Shooter(...)).With(new SunProducer(...)), and one AddPacket line. Compare with the Repeater by inheritance.</a:t>
+              <a:t>Pairs, about 7 minutes. One recipe: Defender(...).With(new Shooter(...)).With(new GoldProducer(...)), and one AddCard line. Compare with the Wizard by inheritance.</a:t>
             </a:r>
           </a:p>
         </p:txBody>
@@ -2374,7 +2374,7 @@
           <a:lstStyle/>
           <a:p>
             <a:r>
-              <a:t>Pairs, about 7 minutes. Peashooter.Update fires one pea, with its interval as a private constant. A subclass cannot change either without Peashooter opening up (a virtual method or a protected field).</a:t>
+              <a:t>Pairs, about 7 minutes. Archer.Update fires one arrow, with its interval as a private constant. A subclass cannot change either without Archer opening up (a virtual method or a protected field).</a:t>
             </a:r>
           </a:p>
         </p:txBody>
@@ -2432,7 +2432,7 @@
           <a:lstStyle/>
           <a:p>
             <a:r>
-              <a:t>Pairs, about 5 minutes. Window.Title = $"{cell}" in Update. Off the lawn, CellAt returns null: not every point is a cell.</a:t>
+              <a:t>Pairs, about 5 minutes. Window.Title = $"{cell}" in Update. Off the field, CellAt returns null: not every point is a cell.</a:t>
             </a:r>
           </a:p>
         </p:txBody>
@@ -2584,7 +2584,7 @@
           <a:lstStyle/>
           <a:p>
             <a:r>
-              <a:t>Start from Pvz4. Ask after the first: did the Tall-nut or the Flag Zombie need any code? Only data.</a:t>
+              <a:t>Start from Pvz4. Ask after the first: did the Guard or the Runner need any code? Only data.</a:t>
             </a:r>
           </a:p>
         </p:txBody>
@@ -2736,12 +2736,12 @@
           <a:lstStyle/>
           <a:p>
             <a:r>
-              <a:t>Pairs, about 6 minutes. Copy the conehead test. Armour takes 12 (8 left), then 12 more: 8 absorbed, 4 through, so health 6: still standing.</a:t>
-            </a:r>
-          </a:p>
-          <a:p>
-            <a:r>
-              <a:t>Ask: what would this test need with a ConeheadZombie subclass? The whole class and its bases.</a:t>
+              <a:t>Pairs, about 6 minutes. Copy the shieldbearer test. Armour takes 12 (8 left), then 12 more: 8 absorbed, 4 through, so health 6: still standing.</a:t>
+            </a:r>
+          </a:p>
+          <a:p>
+            <a:r>
+              <a:t>Ask: what would this test need with a ShieldbearerGoblin subclass? The whole class and its bases.</a:t>
             </a:r>
           </a:p>
         </p:txBody>
@@ -2799,12 +2799,12 @@
           <a:lstStyle/>
           <a:p>
             <a:r>
-              <a:t>A grid: one division finds the cell. Suns and packets are separate objects: check each.</a:t>
-            </a:r>
-          </a:p>
-          <a:p>
-            <a:r>
-              <a:t>When they overlap, the order decides: sun first, then packets, then the lawn. And show what a click will do before it happens.</a:t>
+              <a:t>A grid: one division finds the cell. Coins and cards are separate objects: check each.</a:t>
+            </a:r>
+          </a:p>
+          <a:p>
+            <a:r>
+              <a:t>When they overlap, the order decides: coins first, then cards, then the field. And show what a click will do before it happens.</a:t>
             </a:r>
           </a:p>
         </p:txBody>
@@ -6647,7 +6647,7 @@
                   <a:schemeClr val="accent5"/>
                 </a:solidFill>
               </a:rPr>
-              <a:t>Plants and Zombies With Inheritance</a:t>
+              <a:t>Defenders and Goblins With Inheritance</a:t>
             </a:r>
             <a:endParaRPr>
               <a:solidFill>
@@ -6747,7 +6747,7 @@
                   <a:srgbClr val="DEE2E6"/>
                 </a:solidFill>
               </a:rPr>
-              <a:t>Plant</a:t>
+              <a:t>Defender</a:t>
             </a:r>
           </a:p>
         </p:txBody>
@@ -6801,7 +6801,7 @@
                   <a:srgbClr val="DEE2E6"/>
                 </a:solidFill>
               </a:rPr>
-              <a:t>Sunflower</a:t>
+              <a:t>Chest</a:t>
             </a:r>
           </a:p>
         </p:txBody>
@@ -6891,7 +6891,7 @@
                   <a:srgbClr val="DEE2E6"/>
                 </a:solidFill>
               </a:rPr>
-              <a:t>Peashooter</a:t>
+              <a:t>Archer</a:t>
             </a:r>
           </a:p>
         </p:txBody>
@@ -6981,7 +6981,7 @@
                   <a:srgbClr val="DEE2E6"/>
                 </a:solidFill>
               </a:rPr>
-              <a:t>WallNut</a:t>
+              <a:t>Knight</a:t>
             </a:r>
           </a:p>
         </p:txBody>
@@ -7071,7 +7071,7 @@
                   <a:srgbClr val="DEE2E6"/>
                 </a:solidFill>
               </a:rPr>
-              <a:t>Zombie</a:t>
+              <a:t>Goblin</a:t>
             </a:r>
           </a:p>
         </p:txBody>
@@ -7125,7 +7125,7 @@
                   <a:srgbClr val="DEE2E6"/>
                 </a:solidFill>
               </a:rPr>
-              <a:t>Pea</a:t>
+              <a:t>Arrow</a:t>
             </a:r>
           </a:p>
         </p:txBody>
@@ -7179,7 +7179,7 @@
                   <a:srgbClr val="DEE2E6"/>
                 </a:solidFill>
               </a:rPr>
-              <a:t>Sun</a:t>
+              <a:t>Coin</a:t>
             </a:r>
           </a:p>
         </p:txBody>
@@ -7374,7 +7374,7 @@
                   <a:srgbClr val="DEE2E6"/>
                 </a:solidFill>
               </a:rPr>
-              <a:t>Repeater</a:t>
+              <a:t>Wizard</a:t>
             </a:r>
           </a:p>
           <a:p>
@@ -7385,7 +7385,7 @@
                   <a:srgbClr val="9AA3AB"/>
                 </a:solidFill>
               </a:rPr>
-              <a:t>a Peashooter subclass</a:t>
+              <a:t>an Archer subclass</a:t>
             </a:r>
           </a:p>
           <a:p>
@@ -7450,7 +7450,7 @@
                   <a:srgbClr val="DEE2E6"/>
                 </a:solidFill>
               </a:rPr>
-              <a:t>Conehead</a:t>
+              <a:t>Shieldbearer</a:t>
             </a:r>
           </a:p>
           <a:p>
@@ -7461,7 +7461,7 @@
                   <a:srgbClr val="9AA3AB"/>
                 </a:solidFill>
               </a:rPr>
-              <a:t>a Zombie subclass;</a:t>
+              <a:t>a Goblin subclass;</a:t>
             </a:r>
           </a:p>
           <a:p>
@@ -7472,7 +7472,7 @@
                   <a:srgbClr val="9AA3AB"/>
                 </a:solidFill>
               </a:rPr>
-              <a:t>armour for a plant: copy it</a:t>
+              <a:t>armour for a defender: copy it</a:t>
             </a:r>
           </a:p>
         </p:txBody>
@@ -7528,7 +7528,7 @@
                   <a:srgbClr val="DEE2E6"/>
                 </a:solidFill>
               </a:rPr>
-              <a:t>Shoots and makes sun</a:t>
+              <a:t>Shoots and makes gold</a:t>
             </a:r>
           </a:p>
           <a:p>
@@ -7626,7 +7626,7 @@
                   <a:srgbClr val="9AA3AB"/>
                 </a:solidFill>
               </a:rPr>
-              <a:t>a zombie isn’t a plant</a:t>
+              <a:t>a goblin isn’t a defender</a:t>
             </a:r>
           </a:p>
         </p:txBody>
@@ -7786,7 +7786,7 @@
             </a:pPr>
             <a:r>
               <a:rPr lang="en" sz="1800"/>
-              <a:t>Pvz1: plants and zombies as a class hierarchy</a:t>
+              <a:t>Pvz1: defenders and goblins as a class hierarchy</a:t>
             </a:r>
             <a:endParaRPr sz="1800"/>
           </a:p>
@@ -7836,7 +7836,7 @@
             </a:pPr>
             <a:r>
               <a:rPr lang="en"/>
-              <a:t>Try It: A Repeater, by Inheritance</a:t>
+              <a:t>Try It: A Wizard, by Inheritance</a:t>
             </a:r>
             <a:endParaRPr/>
           </a:p>
@@ -7891,7 +7891,7 @@
             </a:pPr>
             <a:r>
               <a:rPr lang="en"/>
-              <a:t>Make a Repeater, a Peashooter that shoots two peas</a:t>
+              <a:t>Make a Wizard, an Archer that shoots two arrows</a:t>
             </a:r>
             <a:endParaRPr/>
           </a:p>
@@ -7908,7 +7908,7 @@
             </a:pPr>
             <a:r>
               <a:rPr lang="en"/>
-              <a:t>How far do you get before Peashooter has to change?</a:t>
+              <a:t>How far do you get before Archer has to change?</a:t>
             </a:r>
             <a:endParaRPr/>
           </a:p>
@@ -8086,7 +8086,7 @@
                   <a:srgbClr val="6C757D"/>
                 </a:solidFill>
               </a:rPr>
-              <a:t>Health, Shooter, SunProducer, Walker, Eater, Armour, SpriteRenderer</a:t>
+              <a:t>Health, Shooter, GoldProducer, Walker, Attacker, Armour, SpriteRenderer</a:t>
             </a:r>
             <a:endParaRPr/>
           </a:p>
@@ -8862,7 +8862,7 @@
                   <a:srgbClr val="DEE2E6"/>
                 </a:solidFill>
               </a:rPr>
-              <a:t>No classes for plants or zombies</a:t>
+              <a:t>No classes for defenders or goblins</a:t>
             </a:r>
             <a:endParaRPr/>
           </a:p>
@@ -8910,7 +8910,7 @@
                   <a:srgbClr val="DEE2E6"/>
                 </a:solidFill>
               </a:rPr>
-              <a:t>Repeater, Conehead: no new classes</a:t>
+              <a:t>Wizard, Shieldbearer: no new classes</a:t>
             </a:r>
             <a:endParaRPr/>
           </a:p>
@@ -8934,7 +8934,7 @@
                   <a:srgbClr val="DEE2E6"/>
                 </a:solidFill>
               </a:rPr>
-              <a:t>Shoots and makes sun: two .With calls</a:t>
+              <a:t>Shoots and makes gold: two .With calls</a:t>
             </a:r>
             <a:endParaRPr/>
           </a:p>
@@ -8958,7 +8958,7 @@
                   <a:srgbClr val="DEE2E6"/>
                 </a:solidFill>
               </a:rPr>
-              <a:t>Health: written once, for plants and zombies</a:t>
+              <a:t>Health: written once, for defenders and goblins</a:t>
             </a:r>
             <a:endParaRPr/>
           </a:p>
@@ -9009,7 +9009,7 @@
                 <a:cs typeface="Consolas"/>
                 <a:sym typeface="Consolas"/>
               </a:rPr>
-              <a:t>Entity Sunflower(World world) =&gt;</a:t>
+              <a:t>Entity Chest(World world) =&gt;</a:t>
             </a:r>
             <a:endParaRPr sz="1000">
               <a:solidFill>
@@ -9047,7 +9047,7 @@
                 <a:cs typeface="Consolas"/>
                 <a:sym typeface="Consolas"/>
               </a:rPr>
-              <a:t>    Plant(world, "sunflower", 6)</a:t>
+              <a:t>    Defender(world, "chest", 6)</a:t>
             </a:r>
             <a:endParaRPr sz="1000">
               <a:solidFill>
@@ -9085,7 +9085,7 @@
                 <a:cs typeface="Consolas"/>
                 <a:sym typeface="Consolas"/>
               </a:rPr>
-              <a:t>        .With(new SunProducer(12, 25));</a:t>
+              <a:t>        .With(new GoldProducer(9, 25));</a:t>
             </a:r>
             <a:endParaRPr sz="1000">
               <a:solidFill>
@@ -9123,7 +9123,7 @@
                 <a:cs typeface="Consolas"/>
                 <a:sym typeface="Consolas"/>
               </a:rPr>
-              <a:t>Entity Repeater(World world) =&gt;</a:t>
+              <a:t>Entity Wizard(World world) =&gt;</a:t>
             </a:r>
             <a:endParaRPr sz="1000">
               <a:solidFill>
@@ -9161,7 +9161,7 @@
                 <a:cs typeface="Consolas"/>
                 <a:sym typeface="Consolas"/>
               </a:rPr>
-              <a:t>    Plant(world, "repeater", 6)</a:t>
+              <a:t>    Defender(world, "wizard", 6)</a:t>
             </a:r>
             <a:endParaRPr sz="1000">
               <a:solidFill>
@@ -9275,7 +9275,7 @@
                 <a:cs typeface="Consolas"/>
                 <a:sym typeface="Consolas"/>
               </a:rPr>
-              <a:t>Entity Zombie(World world) =&gt;</a:t>
+              <a:t>Entity Goblin(World world) =&gt;</a:t>
             </a:r>
             <a:endParaRPr sz="1000">
               <a:solidFill>
@@ -9351,7 +9351,7 @@
                 <a:cs typeface="Consolas"/>
                 <a:sym typeface="Consolas"/>
               </a:rPr>
-              <a:t>        .With(new SpriteRenderer(zombie))</a:t>
+              <a:t>        .With(new SpriteRenderer(goblin))</a:t>
             </a:r>
             <a:endParaRPr sz="1000">
               <a:solidFill>
@@ -9427,7 +9427,7 @@
                 <a:cs typeface="Consolas"/>
                 <a:sym typeface="Consolas"/>
               </a:rPr>
-              <a:t>        .With(new Walker(16))</a:t>
+              <a:t>        .With(new Walker(28))</a:t>
             </a:r>
             <a:endParaRPr sz="1000">
               <a:solidFill>
@@ -9465,7 +9465,7 @@
                 <a:cs typeface="Consolas"/>
                 <a:sym typeface="Consolas"/>
               </a:rPr>
-              <a:t>        .With(new Eater(1));</a:t>
+              <a:t>        .With(new Attacker(1));</a:t>
             </a:r>
             <a:endParaRPr sz="1000">
               <a:solidFill>
@@ -9503,7 +9503,7 @@
                 <a:cs typeface="Consolas"/>
                 <a:sym typeface="Consolas"/>
               </a:rPr>
-              <a:t>Entity Conehead(World world) =&gt;</a:t>
+              <a:t>Entity Shieldbearer(World world) =&gt;</a:t>
             </a:r>
             <a:endParaRPr sz="1000">
               <a:solidFill>
@@ -9541,7 +9541,7 @@
                 <a:cs typeface="Consolas"/>
                 <a:sym typeface="Consolas"/>
               </a:rPr>
-              <a:t>    Zombie(world).With(new Armour(18, cone));</a:t>
+              <a:t>    Goblin(world).With(new Armour(18, shield));</a:t>
             </a:r>
             <a:endParaRPr sz="1000">
               <a:solidFill>
@@ -9682,7 +9682,7 @@
                   <a:srgbClr val="6C757D"/>
                 </a:solidFill>
               </a:rPr>
-              <a:t>Walker stops while the Eater eats</a:t>
+              <a:t>Walker stops while the Attacker attacks</a:t>
             </a:r>
             <a:endParaRPr/>
           </a:p>
@@ -9754,7 +9754,7 @@
                   <a:srgbClr val="6C757D"/>
                 </a:solidFill>
               </a:rPr>
-              <a:t>Shooter: a zombie ahead in my row?</a:t>
+              <a:t>Shooter: a goblin ahead in my row?</a:t>
             </a:r>
             <a:endParaRPr/>
           </a:p>
@@ -9967,7 +9967,7 @@
                 <a:cs typeface="Consolas"/>
                 <a:sym typeface="Consolas"/>
               </a:rPr>
-              <a:t>    if (Owner.Get&lt;Eater&gt;()?.IsEating == true)</a:t>
+              <a:t>    if (Owner.Get&lt;Attacker&gt;()?.IsAttacking == true)</a:t>
             </a:r>
             <a:endParaRPr sz="1000">
               <a:solidFill>
@@ -10271,7 +10271,7 @@
                 <a:cs typeface="Consolas"/>
                 <a:sym typeface="Consolas"/>
               </a:rPr>
-              <a:t>    World.FirstZombieAhead(Owner.Row,</a:t>
+              <a:t>    World.FirstGoblinAhead(Owner.Row,</a:t>
             </a:r>
             <a:endParaRPr sz="1000">
               <a:solidFill>
@@ -10531,7 +10531,7 @@
                   <a:srgbClr val="9AA3AB"/>
                 </a:solidFill>
               </a:rPr>
-              <a:t>Get&lt;Eater&gt;() searches a list,</a:t>
+              <a:t>Get&lt;Attacker&gt;() searches a list,</a:t>
             </a:r>
           </a:p>
           <a:p>
@@ -10685,7 +10685,7 @@
                   <a:srgbClr val="9AA3AB"/>
                 </a:solidFill>
               </a:rPr>
-              <a:t>a pea hits a zombie:</a:t>
+              <a:t>an arrow hits a goblin:</a:t>
             </a:r>
           </a:p>
           <a:p>
@@ -10696,7 +10696,7 @@
                   <a:srgbClr val="9AA3AB"/>
                 </a:solidFill>
               </a:rPr>
-              <a:t>the pea’s rule, or the zombie’s?</a:t>
+              <a:t>the arrow’s rule, or the goblin’s?</a:t>
             </a:r>
           </a:p>
         </p:txBody>
@@ -10834,7 +10834,7 @@
             </a:pPr>
             <a:r>
               <a:rPr lang="en"/>
-              <a:t>An entity with only the parts under test: no lawn, no textures, no game running</a:t>
+              <a:t>An entity with only the parts under test: no field, no textures, no game running</a:t>
             </a:r>
             <a:endParaRPr/>
           </a:p>
@@ -10901,7 +10901,7 @@
             </a:pPr>
             <a:r>
               <a:rPr lang="en"/>
-              <a:t>Try It: A Buckethead Test</a:t>
+              <a:t>Try It: An Ironclad Test</a:t>
             </a:r>
             <a:endParaRPr/>
           </a:p>
@@ -10956,7 +10956,7 @@
             </a:pPr>
             <a:r>
               <a:rPr lang="en"/>
-              <a:t>A buckethead: armour 20, health 10</a:t>
+              <a:t>An Ironclad: armour 20, health 10</a:t>
             </a:r>
             <a:endParaRPr/>
           </a:p>
@@ -11280,7 +11280,7 @@
             </a:pPr>
             <a:r>
               <a:rPr lang="en"/>
-              <a:t>Try It: A New Plant From Parts</a:t>
+              <a:t>Try It: A New Defender From Parts</a:t>
             </a:r>
             <a:endParaRPr/>
           </a:p>
@@ -11335,7 +11335,7 @@
             </a:pPr>
             <a:r>
               <a:rPr lang="en"/>
-              <a:t>A plant that shoots and makes sun</a:t>
+              <a:t>A defender that shoots and makes gold</a:t>
             </a:r>
             <a:endParaRPr/>
           </a:p>
@@ -11352,7 +11352,7 @@
             </a:pPr>
             <a:r>
               <a:rPr lang="en"/>
-              <a:t>Give it a packet in Game1 (sunflower sprite)</a:t>
+              <a:t>Give it a card in Game1 (chest sprite)</a:t>
             </a:r>
             <a:endParaRPr/>
           </a:p>
@@ -11475,7 +11475,7 @@
                   <a:srgbClr val="DEE2E6"/>
                 </a:solidFill>
               </a:rPr>
-              <a:t>A peashooter’s cost: not in any one peashooter</a:t>
+              <a:t>An archer’s cost: not in any one archer</a:t>
             </a:r>
             <a:endParaRPr/>
           </a:p>
@@ -11499,7 +11499,7 @@
                   <a:srgbClr val="DEE2E6"/>
                 </a:solidFill>
               </a:rPr>
-              <a:t>One PlantType per kind of plant</a:t>
+              <a:t>One DefenderType per kind of defender</a:t>
             </a:r>
             <a:endParaRPr/>
           </a:p>
@@ -11523,7 +11523,7 @@
                   <a:srgbClr val="6C757D"/>
                 </a:solidFill>
               </a:rPr>
-              <a:t>Loaded from plants.json</a:t>
+              <a:t>Loaded from defenders.json</a:t>
             </a:r>
             <a:endParaRPr/>
           </a:p>
@@ -11622,7 +11622,7 @@
                 <a:cs typeface="Consolas"/>
                 <a:sym typeface="Consolas"/>
               </a:rPr>
-              <a:t>// plants.json</a:t>
+              <a:t>// defenders.json</a:t>
             </a:r>
             <a:endParaRPr sz="1000">
               <a:solidFill>
@@ -11660,7 +11660,7 @@
                 <a:cs typeface="Consolas"/>
                 <a:sym typeface="Consolas"/>
               </a:rPr>
-              <a:t>{ "name": "Sunflower",</a:t>
+              <a:t>{ "name": "Chest",</a:t>
             </a:r>
             <a:endParaRPr sz="1000">
               <a:solidFill>
@@ -11698,7 +11698,7 @@
                 <a:cs typeface="Consolas"/>
                 <a:sym typeface="Consolas"/>
               </a:rPr>
-              <a:t>  "sprite": "sunflower",</a:t>
+              <a:t>  "sprite": "chest",</a:t>
             </a:r>
             <a:endParaRPr sz="1000">
               <a:solidFill>
@@ -11812,7 +11812,7 @@
                 <a:cs typeface="Consolas"/>
                 <a:sym typeface="Consolas"/>
               </a:rPr>
-              <a:t>  "sunProducer": {</a:t>
+              <a:t>  "goldProducer": {</a:t>
             </a:r>
             <a:endParaRPr sz="1000">
               <a:solidFill>
@@ -11850,7 +11850,7 @@
                 <a:cs typeface="Consolas"/>
                 <a:sym typeface="Consolas"/>
               </a:rPr>
-              <a:t>    "interval": 12, "amount": 25 } },</a:t>
+              <a:t>    "interval": 9, "amount": 25 } },</a:t>
             </a:r>
             <a:endParaRPr sz="1000">
               <a:solidFill>
@@ -11888,7 +11888,7 @@
                 <a:cs typeface="Consolas"/>
                 <a:sym typeface="Consolas"/>
               </a:rPr>
-              <a:t>{ "name": "Repeater",</a:t>
+              <a:t>{ "name": "Wizard",</a:t>
             </a:r>
             <a:endParaRPr sz="1000">
               <a:solidFill>
@@ -11926,7 +11926,7 @@
                 <a:cs typeface="Consolas"/>
                 <a:sym typeface="Consolas"/>
               </a:rPr>
-              <a:t>  "sprite": "repeater",</a:t>
+              <a:t>  "sprite": "wizard",</a:t>
             </a:r>
             <a:endParaRPr sz="1000">
               <a:solidFill>
@@ -12281,7 +12281,7 @@
                   <a:srgbClr val="6C757D"/>
                 </a:solidFill>
               </a:rPr>
-              <a:t>A Buckethead: a zombie type with armour</a:t>
+              <a:t>An Ironclad: a goblin type with armour</a:t>
             </a:r>
             <a:endParaRPr/>
           </a:p>
@@ -12329,7 +12329,7 @@
                   <a:srgbClr val="6C757D"/>
                 </a:solidFill>
               </a:rPr>
-              <a:t>The Cherry Bomb: Explode</a:t>
+              <a:t>The Bomb: Explode</a:t>
             </a:r>
             <a:endParaRPr/>
           </a:p>
@@ -12456,7 +12456,7 @@
                 <a:cs typeface="Consolas"/>
                 <a:sym typeface="Consolas"/>
               </a:rPr>
-              <a:t>    var plant = new Entity(world)</a:t>
+              <a:t>    var defender = new Entity(world)</a:t>
             </a:r>
             <a:endParaRPr sz="1000">
               <a:solidFill>
@@ -12684,7 +12684,7 @@
                 <a:cs typeface="Consolas"/>
                 <a:sym typeface="Consolas"/>
               </a:rPr>
-              <a:t>        plant.Add(new Shooter(Shooter.Interval,</a:t>
+              <a:t>        defender.Add(new Shooter(Shooter.Interval,</a:t>
             </a:r>
             <a:endParaRPr sz="1000">
               <a:solidFill>
@@ -12760,7 +12760,7 @@
                 <a:cs typeface="Consolas"/>
                 <a:sym typeface="Consolas"/>
               </a:rPr>
-              <a:t>    if (SunProducer != null)</a:t>
+              <a:t>    if (GoldProducer != null)</a:t>
             </a:r>
             <a:endParaRPr sz="1000">
               <a:solidFill>
@@ -12798,7 +12798,7 @@
                 <a:cs typeface="Consolas"/>
                 <a:sym typeface="Consolas"/>
               </a:rPr>
-              <a:t>        plant.Add(new SunProducer(</a:t>
+              <a:t>        defender.Add(new GoldProducer(</a:t>
             </a:r>
             <a:endParaRPr sz="1000">
               <a:solidFill>
@@ -12836,7 +12836,7 @@
                 <a:cs typeface="Consolas"/>
                 <a:sym typeface="Consolas"/>
               </a:rPr>
-              <a:t>            SunProducer.Interval, SunProducer.Amount));</a:t>
+              <a:t>            GoldProducer.Interval, GoldProducer.Amount));</a:t>
             </a:r>
             <a:endParaRPr sz="1000">
               <a:solidFill>
@@ -12874,7 +12874,7 @@
                 <a:cs typeface="Consolas"/>
                 <a:sym typeface="Consolas"/>
               </a:rPr>
-              <a:t>    return plant;</a:t>
+              <a:t>    return defender;</a:t>
             </a:r>
             <a:endParaRPr sz="1000">
               <a:solidFill>
@@ -13241,7 +13241,7 @@
                   <a:srgbClr val="DEE2E6"/>
                 </a:solidFill>
               </a:rPr>
-              <a:t>A plant’s cost: in each plant, or in its type?</a:t>
+              <a:t>A defender’s cost: in each defender, or in its type?</a:t>
             </a:r>
           </a:p>
         </p:txBody>
@@ -13367,7 +13367,7 @@
             </a:pPr>
             <a:r>
               <a:rPr lang="en" sz="1800"/>
-              <a:t>Pvz3: plant and zombie types from JSON</a:t>
+              <a:t>Pvz3: defender and goblin types from JSON</a:t>
             </a:r>
             <a:endParaRPr sz="1800"/>
           </a:p>
@@ -13455,7 +13455,7 @@
             </a:pPr>
             <a:r>
               <a:rPr lang="en"/>
-              <a:t>In plants.json:</a:t>
+              <a:t>In defenders.json:</a:t>
             </a:r>
             <a:endParaRPr/>
           </a:p>
@@ -13472,7 +13472,7 @@
             </a:pPr>
             <a:r>
               <a:rPr lang="en"/>
-              <a:t>A Wall-nut that costs 25 and takes twice the bites</a:t>
+              <a:t>A Knight that costs 25 and takes twice the hits</a:t>
             </a:r>
             <a:endParaRPr/>
           </a:p>
@@ -13489,7 +13489,7 @@
             </a:pPr>
             <a:r>
               <a:rPr lang="en"/>
-              <a:t>A Sunflower that makes 50 sun</a:t>
+              <a:t>A Chest that makes 50 gold</a:t>
             </a:r>
             <a:endParaRPr/>
           </a:p>
@@ -13630,7 +13630,7 @@
             </a:pPr>
             <a:r>
               <a:rPr lang="en"/>
-              <a:t>Starting sun, sun from the sky, which zombie comes when</a:t>
+              <a:t>Starting gold, gold from the sky, which goblin comes when</a:t>
             </a:r>
             <a:endParaRPr/>
           </a:p>
@@ -13647,7 +13647,7 @@
             </a:pPr>
             <a:r>
               <a:rPr lang="en"/>
-              <a:t>Seed packets recharge after planting</a:t>
+              <a:t>Cards recharge after use</a:t>
             </a:r>
             <a:endParaRPr/>
           </a:p>
@@ -13681,7 +13681,7 @@
             </a:pPr>
             <a:r>
               <a:rPr lang="en"/>
-              <a:t>Falling sun: a sun with one more component, Faller</a:t>
+              <a:t>Falling gold: a coin with one more component, Faller</a:t>
             </a:r>
             <a:endParaRPr/>
           </a:p>
@@ -13946,7 +13946,7 @@
             </a:pPr>
             <a:r>
               <a:rPr lang="en"/>
-              <a:t>New types: a Tall-nut and a Flag Zombie. Any code?</a:t>
+              <a:t>New types: a Guard and a Runner. Any code?</a:t>
             </a:r>
             <a:endParaRPr/>
           </a:p>
@@ -13963,7 +13963,7 @@
             </a:pPr>
             <a:r>
               <a:rPr lang="en"/>
-              <a:t>Snow Pea: peas that slow zombies down</a:t>
+              <a:t>Frost Wizard: arrows that slow goblins down</a:t>
             </a:r>
             <a:endParaRPr/>
           </a:p>
@@ -13997,7 +13997,7 @@
             </a:pPr>
             <a:r>
               <a:rPr lang="en"/>
-              <a:t>Pumpkin: armour for plants. Can you reuse Armour?</a:t>
+              <a:t>A shield for defenders. Can you reuse Armour?</a:t>
             </a:r>
             <a:endParaRPr/>
           </a:p>
@@ -14014,7 +14014,7 @@
             </a:pPr>
             <a:r>
               <a:rPr lang="en"/>
-              <a:t>A shovel that removes the plant you click</a:t>
+              <a:t>A pitchfork that sends the defender you click back into the castle</a:t>
             </a:r>
             <a:endParaRPr/>
           </a:p>
@@ -14761,7 +14761,7 @@
           <p:nvPr/>
         </p:nvPicPr>
         <p:blipFill>
-          <a:blip r:embed="rId3"/>
+          <a:blip r:embed="rId4"/>
           <a:stretch>
             <a:fillRect/>
           </a:stretch>
@@ -14769,7 +14769,7 @@
         <p:spPr>
           <a:xfrm>
             <a:off x="1677203" y="1531275"/>
-            <a:ext cx="5789594" cy="3256647"/>
+            <a:ext cx="5789594" cy="3256646"/>
           </a:xfrm>
           <a:prstGeom prst="rect">
             <a:avLst/>
@@ -14884,7 +14884,7 @@
             </a:pPr>
             <a:r>
               <a:rPr lang="en"/>
-              <a:t>PlantType.Create has an if for every component</a:t>
+              <a:t>DefenderType.Create has an if for every component</a:t>
             </a:r>
             <a:endParaRPr/>
           </a:p>
@@ -15690,7 +15690,7 @@
             </a:pPr>
             <a:r>
               <a:rPr lang="en"/>
-              <a:t>Why does inheritance break down for Plants vs. Zombies?</a:t>
+              <a:t>Why does inheritance break down for this game?</a:t>
             </a:r>
             <a:endParaRPr/>
           </a:p>
@@ -17711,7 +17711,7 @@
                 <a:cs typeface="Consolas"/>
                 <a:sym typeface="Consolas"/>
               </a:rPr>
-              <a:t>// Lawn.cs</a:t>
+              <a:t>// Field.cs</a:t>
             </a:r>
             <a:endParaRPr sz="1000">
               <a:solidFill>
@@ -18188,7 +18188,7 @@
                   <a:srgbClr val="DEE2E6"/>
                 </a:solidFill>
               </a:rPr>
-              <a:t>The lawn: a grid</a:t>
+              <a:t>The field: a grid</a:t>
             </a:r>
           </a:p>
           <a:p>
@@ -18264,7 +18264,7 @@
                   <a:srgbClr val="DEE2E6"/>
                 </a:solidFill>
               </a:rPr>
-              <a:t>Suns, seed packets: objects</a:t>
+              <a:t>Coins, cards: objects</a:t>
             </a:r>
           </a:p>
           <a:p>
@@ -18376,7 +18376,7 @@
                   <a:srgbClr val="DEE2E6"/>
                 </a:solidFill>
               </a:rPr>
-              <a:t>Sun</a:t>
+              <a:t>Coins</a:t>
             </a:r>
           </a:p>
         </p:txBody>
@@ -18466,7 +18466,7 @@
                   <a:srgbClr val="DEE2E6"/>
                 </a:solidFill>
               </a:rPr>
-              <a:t>Seed packets</a:t>
+              <a:t>Cards</a:t>
             </a:r>
           </a:p>
         </p:txBody>
@@ -18556,7 +18556,7 @@
                   <a:srgbClr val="DEE2E6"/>
                 </a:solidFill>
               </a:rPr>
-              <a:t>The lawn</a:t>
+              <a:t>The field</a:t>
             </a:r>
           </a:p>
         </p:txBody>
@@ -18590,7 +18590,7 @@
                   <a:srgbClr val="9AA3AB"/>
                 </a:solidFill>
               </a:rPr>
-              <a:t>And show what a click will do, by highlighting the cell with a faint plant.</a:t>
+              <a:t>And show what a click will do, by highlighting the cell with a faint defender.</a:t>
             </a:r>
           </a:p>
         </p:txBody>
@@ -18716,7 +18716,7 @@
             </a:pPr>
             <a:r>
               <a:rPr lang="en" sz="1800"/>
-              <a:t>Pvz0: choose a packet, click a cell to plant</a:t>
+              <a:t>Pvz0: choose a card, click a cell to place a defender</a:t>
             </a:r>
             <a:endParaRPr sz="1800"/>
           </a:p>
@@ -18838,7 +18838,7 @@
             </a:pPr>
             <a:r>
               <a:rPr lang="en"/>
-              <a:t>Move off the lawn: what does CellAt give you?</a:t>
+              <a:t>Move off the field: what does CellAt give you?</a:t>
             </a:r>
             <a:endParaRPr/>
           </a:p>

</xml_diff>

<commit_message>
Plants vs. Zombies deck: the armour test no longer names a goblin type the session hasn't met yet
Co-Authored-By: Claude Opus 5.5 <noreply@anthropic.com>
Claude-Session: https://claude.ai/code/session_012sjsUQBbC7zon57rWHoo9d
</commit_message>
<xml_diff>
--- a/slides/09 Plants vs. Zombies.pptx
+++ b/slides/09 Plants vs. Zombies.pptx
@@ -10901,7 +10901,7 @@
             </a:pPr>
             <a:r>
               <a:rPr lang="en"/>
-              <a:t>Try It: An Ironclad Test</a:t>
+              <a:t>Try It: An Armour Test</a:t>
             </a:r>
             <a:endParaRPr/>
           </a:p>
@@ -10956,7 +10956,7 @@
             </a:pPr>
             <a:r>
               <a:rPr lang="en"/>
-              <a:t>An Ironclad: armour 20, health 10</a:t>
+              <a:t>A goblin with armour 20 and health 10</a:t>
             </a:r>
             <a:endParaRPr/>
           </a:p>

</xml_diff>